<commit_message>
Generalize GuardianRail demo framing
</commit_message>
<xml_diff>
--- a/docs/guardianrail-pitch-deck.pptx
+++ b/docs/guardianrail-pitch-deck.pptx
@@ -2,17 +2,17 @@
 <file path=ppt/presentation.xml><?xml version="1.0" encoding="utf-8"?>
 <p:presentation xmlns:p="http://schemas.openxmlformats.org/presentationml/2006/main">
   <p:sldMasterIdLst>
-    <p:sldMasterId xmlns:r="http://schemas.openxmlformats.org/officeDocument/2006/relationships" id="2147483648" r:id="R89f647ea1c424d0f"/>
+    <p:sldMasterId xmlns:r="http://schemas.openxmlformats.org/officeDocument/2006/relationships" id="2147483648" r:id="R2a37f7ed9b7e419e"/>
   </p:sldMasterIdLst>
   <p:notesMasterIdLst>
-    <p:notesMasterId xmlns:r="http://schemas.openxmlformats.org/officeDocument/2006/relationships" r:id="Re09db1aa50c04266"/>
+    <p:notesMasterId xmlns:r="http://schemas.openxmlformats.org/officeDocument/2006/relationships" r:id="R800aab085bab48dc"/>
   </p:notesMasterIdLst>
   <p:sldIdLst>
-    <p:sldId xmlns:r="http://schemas.openxmlformats.org/officeDocument/2006/relationships" id="256" r:id="Rb1df9245470f476d"/>
-    <p:sldId xmlns:r="http://schemas.openxmlformats.org/officeDocument/2006/relationships" id="257" r:id="Rf33880ac2c75494a"/>
-    <p:sldId xmlns:r="http://schemas.openxmlformats.org/officeDocument/2006/relationships" id="258" r:id="R6628e82b459e4c07"/>
-    <p:sldId xmlns:r="http://schemas.openxmlformats.org/officeDocument/2006/relationships" id="259" r:id="R7c3abcf7edb54223"/>
-    <p:sldId xmlns:r="http://schemas.openxmlformats.org/officeDocument/2006/relationships" id="260" r:id="R89ac73c7027949c9"/>
+    <p:sldId xmlns:r="http://schemas.openxmlformats.org/officeDocument/2006/relationships" id="256" r:id="R6007a72d1f0147c2"/>
+    <p:sldId xmlns:r="http://schemas.openxmlformats.org/officeDocument/2006/relationships" id="257" r:id="Re05daff3971e4a3f"/>
+    <p:sldId xmlns:r="http://schemas.openxmlformats.org/officeDocument/2006/relationships" id="258" r:id="R626e84b2acd7456b"/>
+    <p:sldId xmlns:r="http://schemas.openxmlformats.org/officeDocument/2006/relationships" id="259" r:id="Raeec4d792c434184"/>
+    <p:sldId xmlns:r="http://schemas.openxmlformats.org/officeDocument/2006/relationships" id="260" r:id="R03eaa245a48647d0"/>
   </p:sldIdLst>
   <p:sldSz cx="12192000" cy="6858000"/>
   <p:notesSz cx="6858000" cy="9144000"/>
@@ -823,7 +823,7 @@
   </p:cSld>
   <p:clrMap bg1="lt1" tx1="dk1" bg2="lt2" tx2="dk2" accent1="accent1" accent2="accent2" accent3="accent3" accent4="accent4" accent5="accent5" accent6="accent6" hlink="hlink" folHlink="folHlink"/>
   <p:sldLayoutIdLst>
-    <p:sldLayoutId xmlns:r="http://schemas.openxmlformats.org/officeDocument/2006/relationships" id="2147483649" r:id="R01e954d6734f49e3"/>
+    <p:sldLayoutId xmlns:r="http://schemas.openxmlformats.org/officeDocument/2006/relationships" id="2147483649" r:id="R822684b3706b42a5"/>
   </p:sldLayoutIdLst>
   <p:txStyles>
     <p:titleStyle>
@@ -1122,7 +1122,7 @@
           <p:cNvPr id="1" name="">
             <a:extLst xmlns:a="http://schemas.openxmlformats.org/drawingml/2006/main">
               <a:ext uri="{FF2B5EF4-FFF2-40B4-BE49-F238E27FC236}">
-                <a16:creationId xmlns:a16="http://schemas.microsoft.com/office/drawing/2014/main" id="{13853A22-844B-43F8-9773-A806283814D3}"/>
+                <a16:creationId xmlns:a16="http://schemas.microsoft.com/office/drawing/2014/main" id="{EA7E7E39-1A05-43D0-B76B-44161C5C0ABF}"/>
               </a:ext>
             </a:extLst>
           </p:cNvPr>
@@ -1157,7 +1157,7 @@
           <p:cNvPr id="2" name="">
             <a:extLst xmlns:a="http://schemas.openxmlformats.org/drawingml/2006/main">
               <a:ext uri="{FF2B5EF4-FFF2-40B4-BE49-F238E27FC236}">
-                <a16:creationId xmlns:a16="http://schemas.microsoft.com/office/drawing/2014/main" id="{B4A2AFD2-B40D-45D8-9D81-C7393D03F7AA}"/>
+                <a16:creationId xmlns:a16="http://schemas.microsoft.com/office/drawing/2014/main" id="{4CBAA49A-A164-47F2-9F87-D8268C846D3C}"/>
               </a:ext>
             </a:extLst>
           </p:cNvPr>
@@ -1192,7 +1192,7 @@
           <p:cNvPr id="3" name="">
             <a:extLst xmlns:a="http://schemas.openxmlformats.org/drawingml/2006/main">
               <a:ext uri="{FF2B5EF4-FFF2-40B4-BE49-F238E27FC236}">
-                <a16:creationId xmlns:a16="http://schemas.microsoft.com/office/drawing/2014/main" id="{1A392268-BFD1-48B9-9910-26DDC2A40B12}"/>
+                <a16:creationId xmlns:a16="http://schemas.microsoft.com/office/drawing/2014/main" id="{EAB02938-B1E2-40B2-AE46-BED522B7D3DE}"/>
               </a:ext>
             </a:extLst>
           </p:cNvPr>
@@ -1227,7 +1227,7 @@
           <p:cNvPr id="4" name="">
             <a:extLst xmlns:a="http://schemas.openxmlformats.org/drawingml/2006/main">
               <a:ext uri="{FF2B5EF4-FFF2-40B4-BE49-F238E27FC236}">
-                <a16:creationId xmlns:a16="http://schemas.microsoft.com/office/drawing/2014/main" id="{3996D5A6-FF61-4A3D-8A30-EB92D275715E}"/>
+                <a16:creationId xmlns:a16="http://schemas.microsoft.com/office/drawing/2014/main" id="{330B8FDC-244A-47FF-AC0D-605B4A3D5047}"/>
               </a:ext>
             </a:extLst>
           </p:cNvPr>
@@ -1262,7 +1262,7 @@
           <p:cNvPr id="5" name="">
             <a:extLst xmlns:a="http://schemas.openxmlformats.org/drawingml/2006/main">
               <a:ext uri="{FF2B5EF4-FFF2-40B4-BE49-F238E27FC236}">
-                <a16:creationId xmlns:a16="http://schemas.microsoft.com/office/drawing/2014/main" id="{32E7B4E5-6439-4B8E-9566-29DA771CCC4D}"/>
+                <a16:creationId xmlns:a16="http://schemas.microsoft.com/office/drawing/2014/main" id="{10D92CE9-5B41-4A7C-B683-1266EE82F8AF}"/>
               </a:ext>
             </a:extLst>
           </p:cNvPr>
@@ -1297,7 +1297,7 @@
           <p:cNvPr id="6" name="">
             <a:extLst xmlns:a="http://schemas.openxmlformats.org/drawingml/2006/main">
               <a:ext uri="{FF2B5EF4-FFF2-40B4-BE49-F238E27FC236}">
-                <a16:creationId xmlns:a16="http://schemas.microsoft.com/office/drawing/2014/main" id="{1F542CCB-501B-4E0B-BC70-401FDAD03393}"/>
+                <a16:creationId xmlns:a16="http://schemas.microsoft.com/office/drawing/2014/main" id="{9D18C56C-0CC0-4C34-AAFD-B0837AE54206}"/>
               </a:ext>
             </a:extLst>
           </p:cNvPr>
@@ -1332,7 +1332,7 @@
           <p:cNvPr id="7" name="">
             <a:extLst xmlns:a="http://schemas.openxmlformats.org/drawingml/2006/main">
               <a:ext uri="{FF2B5EF4-FFF2-40B4-BE49-F238E27FC236}">
-                <a16:creationId xmlns:a16="http://schemas.microsoft.com/office/drawing/2014/main" id="{635B827F-F0F3-473F-8183-32AD97D93DEC}"/>
+                <a16:creationId xmlns:a16="http://schemas.microsoft.com/office/drawing/2014/main" id="{EF3D8651-4956-4A5A-9AFE-B9C3982BC065}"/>
               </a:ext>
             </a:extLst>
           </p:cNvPr>
@@ -1367,7 +1367,7 @@
           <p:cNvPr id="8" name="">
             <a:extLst xmlns:a="http://schemas.openxmlformats.org/drawingml/2006/main">
               <a:ext uri="{FF2B5EF4-FFF2-40B4-BE49-F238E27FC236}">
-                <a16:creationId xmlns:a16="http://schemas.microsoft.com/office/drawing/2014/main" id="{16F7E685-ECF8-4EAC-AF02-E3CB276CEE9F}"/>
+                <a16:creationId xmlns:a16="http://schemas.microsoft.com/office/drawing/2014/main" id="{58C56B35-1CB2-4D91-B40D-25A57D7EB9CB}"/>
               </a:ext>
             </a:extLst>
           </p:cNvPr>
@@ -1402,7 +1402,7 @@
           <p:cNvPr id="9" name="">
             <a:extLst xmlns:a="http://schemas.openxmlformats.org/drawingml/2006/main">
               <a:ext uri="{FF2B5EF4-FFF2-40B4-BE49-F238E27FC236}">
-                <a16:creationId xmlns:a16="http://schemas.microsoft.com/office/drawing/2014/main" id="{DBE36C6D-CF3E-4B85-BEBE-00B4F60B355A}"/>
+                <a16:creationId xmlns:a16="http://schemas.microsoft.com/office/drawing/2014/main" id="{A9C1AC32-287D-48E4-9837-AB7245D74CA3}"/>
               </a:ext>
             </a:extLst>
           </p:cNvPr>
@@ -1437,7 +1437,7 @@
           <p:cNvPr id="10" name="">
             <a:extLst xmlns:a="http://schemas.openxmlformats.org/drawingml/2006/main">
               <a:ext uri="{FF2B5EF4-FFF2-40B4-BE49-F238E27FC236}">
-                <a16:creationId xmlns:a16="http://schemas.microsoft.com/office/drawing/2014/main" id="{4024B6FB-D684-46AC-93E8-1D100ED359CD}"/>
+                <a16:creationId xmlns:a16="http://schemas.microsoft.com/office/drawing/2014/main" id="{C970782C-ED21-4361-B746-6D00E66ADAF5}"/>
               </a:ext>
             </a:extLst>
           </p:cNvPr>
@@ -1472,7 +1472,7 @@
           <p:cNvPr id="11" name="">
             <a:extLst xmlns:a="http://schemas.openxmlformats.org/drawingml/2006/main">
               <a:ext uri="{FF2B5EF4-FFF2-40B4-BE49-F238E27FC236}">
-                <a16:creationId xmlns:a16="http://schemas.microsoft.com/office/drawing/2014/main" id="{B3178FF0-1105-450C-BC63-3AFC6205C553}"/>
+                <a16:creationId xmlns:a16="http://schemas.microsoft.com/office/drawing/2014/main" id="{A9C551ED-39DB-44A9-A2EA-E5F00221BD62}"/>
               </a:ext>
             </a:extLst>
           </p:cNvPr>
@@ -1507,7 +1507,7 @@
           <p:cNvPr id="12" name="">
             <a:extLst xmlns:a="http://schemas.openxmlformats.org/drawingml/2006/main">
               <a:ext uri="{FF2B5EF4-FFF2-40B4-BE49-F238E27FC236}">
-                <a16:creationId xmlns:a16="http://schemas.microsoft.com/office/drawing/2014/main" id="{0845546D-8110-4816-9635-524B5977941B}"/>
+                <a16:creationId xmlns:a16="http://schemas.microsoft.com/office/drawing/2014/main" id="{FAC45CD5-D0B9-4C35-A31F-344F3211D195}"/>
               </a:ext>
             </a:extLst>
           </p:cNvPr>
@@ -1542,7 +1542,7 @@
           <p:cNvPr id="13" name="">
             <a:extLst xmlns:a="http://schemas.openxmlformats.org/drawingml/2006/main">
               <a:ext uri="{FF2B5EF4-FFF2-40B4-BE49-F238E27FC236}">
-                <a16:creationId xmlns:a16="http://schemas.microsoft.com/office/drawing/2014/main" id="{F94B1648-5C2F-41A5-A86C-D4B722911C46}"/>
+                <a16:creationId xmlns:a16="http://schemas.microsoft.com/office/drawing/2014/main" id="{D585DE28-4DDC-47CD-A0FA-BC6F1CC47EFD}"/>
               </a:ext>
             </a:extLst>
           </p:cNvPr>
@@ -1577,7 +1577,7 @@
           <p:cNvPr id="14" name="">
             <a:extLst xmlns:a="http://schemas.openxmlformats.org/drawingml/2006/main">
               <a:ext uri="{FF2B5EF4-FFF2-40B4-BE49-F238E27FC236}">
-                <a16:creationId xmlns:a16="http://schemas.microsoft.com/office/drawing/2014/main" id="{B7B28AA8-9D76-46B4-9286-E0C3B9BFE829}"/>
+                <a16:creationId xmlns:a16="http://schemas.microsoft.com/office/drawing/2014/main" id="{1026BFD6-758E-4803-B047-D3D9DF6B4080}"/>
               </a:ext>
             </a:extLst>
           </p:cNvPr>
@@ -1612,7 +1612,7 @@
           <p:cNvPr id="15" name="">
             <a:extLst xmlns:a="http://schemas.openxmlformats.org/drawingml/2006/main">
               <a:ext uri="{FF2B5EF4-FFF2-40B4-BE49-F238E27FC236}">
-                <a16:creationId xmlns:a16="http://schemas.microsoft.com/office/drawing/2014/main" id="{3747FAF2-EF99-4A21-A499-07315EADFAF6}"/>
+                <a16:creationId xmlns:a16="http://schemas.microsoft.com/office/drawing/2014/main" id="{83A94E6B-D4BF-4CD3-8AFF-2B47D3DA7C20}"/>
               </a:ext>
             </a:extLst>
           </p:cNvPr>
@@ -1676,7 +1676,7 @@
           <p:cNvPr id="16" name="">
             <a:extLst xmlns:a="http://schemas.openxmlformats.org/drawingml/2006/main">
               <a:ext uri="{FF2B5EF4-FFF2-40B4-BE49-F238E27FC236}">
-                <a16:creationId xmlns:a16="http://schemas.microsoft.com/office/drawing/2014/main" id="{75A4C0B1-530C-413F-AAEB-350BB1F6F013}"/>
+                <a16:creationId xmlns:a16="http://schemas.microsoft.com/office/drawing/2014/main" id="{01792813-9136-4CF6-894B-5BFFF43AE969}"/>
               </a:ext>
             </a:extLst>
           </p:cNvPr>
@@ -1740,7 +1740,7 @@
           <p:cNvPr id="17" name="">
             <a:extLst xmlns:a="http://schemas.openxmlformats.org/drawingml/2006/main">
               <a:ext uri="{FF2B5EF4-FFF2-40B4-BE49-F238E27FC236}">
-                <a16:creationId xmlns:a16="http://schemas.microsoft.com/office/drawing/2014/main" id="{A529F81C-E765-4440-AE88-BF59C6DDE6D8}"/>
+                <a16:creationId xmlns:a16="http://schemas.microsoft.com/office/drawing/2014/main" id="{DBC1D3AF-60D0-4E30-8040-32CA7619D83C}"/>
               </a:ext>
             </a:extLst>
           </p:cNvPr>
@@ -1794,7 +1794,7 @@
                 <a:ea typeface="Aptos Display"/>
                 <a:cs typeface="Aptos Display"/>
               </a:rPr>
-              <a:t>Interpretable safety for open-weight customer support agents.</a:t>
+              <a:t>Interpretable safety for open-weight regulated agents.</a:t>
             </a:r>
           </a:p>
         </p:txBody>
@@ -1804,7 +1804,7 @@
           <p:cNvPr id="18" name="">
             <a:extLst xmlns:a="http://schemas.openxmlformats.org/drawingml/2006/main">
               <a:ext uri="{FF2B5EF4-FFF2-40B4-BE49-F238E27FC236}">
-                <a16:creationId xmlns:a16="http://schemas.microsoft.com/office/drawing/2014/main" id="{455F04CF-716E-46FC-9FC7-5C05967F50DD}"/>
+                <a16:creationId xmlns:a16="http://schemas.microsoft.com/office/drawing/2014/main" id="{76CE0156-8072-4F6B-BB91-A3B5D0B5BD8E}"/>
               </a:ext>
             </a:extLst>
           </p:cNvPr>
@@ -1868,7 +1868,7 @@
           <p:cNvPr id="19" name="">
             <a:extLst xmlns:a="http://schemas.openxmlformats.org/drawingml/2006/main">
               <a:ext uri="{FF2B5EF4-FFF2-40B4-BE49-F238E27FC236}">
-                <a16:creationId xmlns:a16="http://schemas.microsoft.com/office/drawing/2014/main" id="{F0AF9B8E-1526-4FDC-90F0-B022C4C5434D}"/>
+                <a16:creationId xmlns:a16="http://schemas.microsoft.com/office/drawing/2014/main" id="{D3A39336-103F-480D-83B4-1B07B42D3BD5}"/>
               </a:ext>
             </a:extLst>
           </p:cNvPr>
@@ -1901,7 +1901,7 @@
           <p:cNvPr id="20" name="">
             <a:extLst xmlns:a="http://schemas.openxmlformats.org/drawingml/2006/main">
               <a:ext uri="{FF2B5EF4-FFF2-40B4-BE49-F238E27FC236}">
-                <a16:creationId xmlns:a16="http://schemas.microsoft.com/office/drawing/2014/main" id="{93035FD2-C40F-4996-AC23-FF154BC4AAD8}"/>
+                <a16:creationId xmlns:a16="http://schemas.microsoft.com/office/drawing/2014/main" id="{F1D2AD78-E864-4A68-9281-B4B285F92129}"/>
               </a:ext>
             </a:extLst>
           </p:cNvPr>
@@ -2034,7 +2034,7 @@
           <p:cNvPr id="21" name="">
             <a:extLst xmlns:a="http://schemas.openxmlformats.org/drawingml/2006/main">
               <a:ext uri="{FF2B5EF4-FFF2-40B4-BE49-F238E27FC236}">
-                <a16:creationId xmlns:a16="http://schemas.microsoft.com/office/drawing/2014/main" id="{6AC20815-04B0-4568-9E94-F8B0CD10750C}"/>
+                <a16:creationId xmlns:a16="http://schemas.microsoft.com/office/drawing/2014/main" id="{60CE4FCC-FB7E-4BB1-B366-CEF354F151F9}"/>
               </a:ext>
             </a:extLst>
           </p:cNvPr>
@@ -2098,7 +2098,7 @@
           <p:cNvPr id="22" name="">
             <a:extLst xmlns:a="http://schemas.openxmlformats.org/drawingml/2006/main">
               <a:ext uri="{FF2B5EF4-FFF2-40B4-BE49-F238E27FC236}">
-                <a16:creationId xmlns:a16="http://schemas.microsoft.com/office/drawing/2014/main" id="{24102731-0BA6-402C-8822-5D47ADA98A94}"/>
+                <a16:creationId xmlns:a16="http://schemas.microsoft.com/office/drawing/2014/main" id="{E5397AF9-A42E-4523-9893-DB1435D0FE40}"/>
               </a:ext>
             </a:extLst>
           </p:cNvPr>
@@ -2131,7 +2131,7 @@
           <p:cNvPr id="23" name="">
             <a:extLst xmlns:a="http://schemas.openxmlformats.org/drawingml/2006/main">
               <a:ext uri="{FF2B5EF4-FFF2-40B4-BE49-F238E27FC236}">
-                <a16:creationId xmlns:a16="http://schemas.microsoft.com/office/drawing/2014/main" id="{47F78FBD-A6BA-4C38-9700-271BF553B4EE}"/>
+                <a16:creationId xmlns:a16="http://schemas.microsoft.com/office/drawing/2014/main" id="{6EEB15CC-363F-402C-8CC3-3119FA408D7B}"/>
               </a:ext>
             </a:extLst>
           </p:cNvPr>
@@ -2166,7 +2166,7 @@
           <p:cNvPr id="24" name="">
             <a:extLst xmlns:a="http://schemas.openxmlformats.org/drawingml/2006/main">
               <a:ext uri="{FF2B5EF4-FFF2-40B4-BE49-F238E27FC236}">
-                <a16:creationId xmlns:a16="http://schemas.microsoft.com/office/drawing/2014/main" id="{E54E6973-55C9-4795-A1B6-DFC74F79ECF9}"/>
+                <a16:creationId xmlns:a16="http://schemas.microsoft.com/office/drawing/2014/main" id="{02E3FBAA-397A-46F0-981D-51B257B091F0}"/>
               </a:ext>
             </a:extLst>
           </p:cNvPr>
@@ -2230,7 +2230,7 @@
           <p:cNvPr id="25" name="">
             <a:extLst xmlns:a="http://schemas.openxmlformats.org/drawingml/2006/main">
               <a:ext uri="{FF2B5EF4-FFF2-40B4-BE49-F238E27FC236}">
-                <a16:creationId xmlns:a16="http://schemas.microsoft.com/office/drawing/2014/main" id="{E6F78416-1A3D-43D1-93B1-82EF802ABE75}"/>
+                <a16:creationId xmlns:a16="http://schemas.microsoft.com/office/drawing/2014/main" id="{30AE1C6D-B5BB-4C05-9532-5B7DFD696F2B}"/>
               </a:ext>
             </a:extLst>
           </p:cNvPr>
@@ -2294,7 +2294,7 @@
           <p:cNvPr id="26" name="">
             <a:extLst xmlns:a="http://schemas.openxmlformats.org/drawingml/2006/main">
               <a:ext uri="{FF2B5EF4-FFF2-40B4-BE49-F238E27FC236}">
-                <a16:creationId xmlns:a16="http://schemas.microsoft.com/office/drawing/2014/main" id="{09FD8FC0-53F5-44FA-9461-D79B5DC2D572}"/>
+                <a16:creationId xmlns:a16="http://schemas.microsoft.com/office/drawing/2014/main" id="{5C8F627C-B9D6-462D-834A-199BC075DD18}"/>
               </a:ext>
             </a:extLst>
           </p:cNvPr>
@@ -2358,7 +2358,7 @@
           <p:cNvPr id="27" name="">
             <a:extLst xmlns:a="http://schemas.openxmlformats.org/drawingml/2006/main">
               <a:ext uri="{FF2B5EF4-FFF2-40B4-BE49-F238E27FC236}">
-                <a16:creationId xmlns:a16="http://schemas.microsoft.com/office/drawing/2014/main" id="{8FFA32BF-16D0-4707-BCF9-73EB847E5DE3}"/>
+                <a16:creationId xmlns:a16="http://schemas.microsoft.com/office/drawing/2014/main" id="{8BC4D23E-463E-4976-91EB-3967AFA53401}"/>
               </a:ext>
             </a:extLst>
           </p:cNvPr>
@@ -2391,7 +2391,7 @@
           <p:cNvPr id="28" name="">
             <a:extLst xmlns:a="http://schemas.openxmlformats.org/drawingml/2006/main">
               <a:ext uri="{FF2B5EF4-FFF2-40B4-BE49-F238E27FC236}">
-                <a16:creationId xmlns:a16="http://schemas.microsoft.com/office/drawing/2014/main" id="{A8E11B0B-E9A5-4247-9FE7-7D63BD36B6C4}"/>
+                <a16:creationId xmlns:a16="http://schemas.microsoft.com/office/drawing/2014/main" id="{D116E42D-45AE-401F-8AD8-AE5DD19EEC56}"/>
               </a:ext>
             </a:extLst>
           </p:cNvPr>
@@ -2426,7 +2426,7 @@
           <p:cNvPr id="29" name="">
             <a:extLst xmlns:a="http://schemas.openxmlformats.org/drawingml/2006/main">
               <a:ext uri="{FF2B5EF4-FFF2-40B4-BE49-F238E27FC236}">
-                <a16:creationId xmlns:a16="http://schemas.microsoft.com/office/drawing/2014/main" id="{9136BB26-D53E-4EC3-BB8E-4BEBDB91360A}"/>
+                <a16:creationId xmlns:a16="http://schemas.microsoft.com/office/drawing/2014/main" id="{D5246ABE-C41D-48BF-9CB6-BB97FF4E7701}"/>
               </a:ext>
             </a:extLst>
           </p:cNvPr>
@@ -2490,7 +2490,7 @@
           <p:cNvPr id="30" name="">
             <a:extLst xmlns:a="http://schemas.openxmlformats.org/drawingml/2006/main">
               <a:ext uri="{FF2B5EF4-FFF2-40B4-BE49-F238E27FC236}">
-                <a16:creationId xmlns:a16="http://schemas.microsoft.com/office/drawing/2014/main" id="{5705ADDE-98E7-4EF4-B495-2F2C17DF85A6}"/>
+                <a16:creationId xmlns:a16="http://schemas.microsoft.com/office/drawing/2014/main" id="{982337AE-05BF-4AEA-B5D9-BAAE1E854E44}"/>
               </a:ext>
             </a:extLst>
           </p:cNvPr>
@@ -2554,7 +2554,7 @@
           <p:cNvPr id="31" name="">
             <a:extLst xmlns:a="http://schemas.openxmlformats.org/drawingml/2006/main">
               <a:ext uri="{FF2B5EF4-FFF2-40B4-BE49-F238E27FC236}">
-                <a16:creationId xmlns:a16="http://schemas.microsoft.com/office/drawing/2014/main" id="{CEEF60F4-599F-4372-8CD3-22F9FF2B43D0}"/>
+                <a16:creationId xmlns:a16="http://schemas.microsoft.com/office/drawing/2014/main" id="{57A28DCB-5E0C-40EB-82EA-A24720EB422B}"/>
               </a:ext>
             </a:extLst>
           </p:cNvPr>
@@ -2618,7 +2618,7 @@
           <p:cNvPr id="32" name="">
             <a:extLst xmlns:a="http://schemas.openxmlformats.org/drawingml/2006/main">
               <a:ext uri="{FF2B5EF4-FFF2-40B4-BE49-F238E27FC236}">
-                <a16:creationId xmlns:a16="http://schemas.microsoft.com/office/drawing/2014/main" id="{B1DEED00-B1F6-4C72-B1D1-FDD2896698CD}"/>
+                <a16:creationId xmlns:a16="http://schemas.microsoft.com/office/drawing/2014/main" id="{057699C1-AB3B-4FA1-A3EC-2404FBDCE950}"/>
               </a:ext>
             </a:extLst>
           </p:cNvPr>
@@ -2651,7 +2651,7 @@
           <p:cNvPr id="33" name="">
             <a:extLst xmlns:a="http://schemas.openxmlformats.org/drawingml/2006/main">
               <a:ext uri="{FF2B5EF4-FFF2-40B4-BE49-F238E27FC236}">
-                <a16:creationId xmlns:a16="http://schemas.microsoft.com/office/drawing/2014/main" id="{8A54D6DB-5599-4F5D-951E-0351862C7005}"/>
+                <a16:creationId xmlns:a16="http://schemas.microsoft.com/office/drawing/2014/main" id="{4923D3BB-FBC3-467C-A08E-BE74B07C4BEC}"/>
               </a:ext>
             </a:extLst>
           </p:cNvPr>
@@ -2686,7 +2686,7 @@
           <p:cNvPr id="34" name="">
             <a:extLst xmlns:a="http://schemas.openxmlformats.org/drawingml/2006/main">
               <a:ext uri="{FF2B5EF4-FFF2-40B4-BE49-F238E27FC236}">
-                <a16:creationId xmlns:a16="http://schemas.microsoft.com/office/drawing/2014/main" id="{9AF800E1-B203-4A41-B370-F5B42C8209FC}"/>
+                <a16:creationId xmlns:a16="http://schemas.microsoft.com/office/drawing/2014/main" id="{606309F5-0D5D-416A-87EF-E3D69BD49959}"/>
               </a:ext>
             </a:extLst>
           </p:cNvPr>
@@ -2750,7 +2750,7 @@
           <p:cNvPr id="35" name="">
             <a:extLst xmlns:a="http://schemas.openxmlformats.org/drawingml/2006/main">
               <a:ext uri="{FF2B5EF4-FFF2-40B4-BE49-F238E27FC236}">
-                <a16:creationId xmlns:a16="http://schemas.microsoft.com/office/drawing/2014/main" id="{9ED00DCC-503F-408D-859A-37FA4B5C9C22}"/>
+                <a16:creationId xmlns:a16="http://schemas.microsoft.com/office/drawing/2014/main" id="{E31736D8-19CE-48FD-9022-5CD867EE50FA}"/>
               </a:ext>
             </a:extLst>
           </p:cNvPr>
@@ -2814,7 +2814,7 @@
           <p:cNvPr id="36" name="">
             <a:extLst xmlns:a="http://schemas.openxmlformats.org/drawingml/2006/main">
               <a:ext uri="{FF2B5EF4-FFF2-40B4-BE49-F238E27FC236}">
-                <a16:creationId xmlns:a16="http://schemas.microsoft.com/office/drawing/2014/main" id="{B35C0253-7869-45E5-843B-4F6D77C90453}"/>
+                <a16:creationId xmlns:a16="http://schemas.microsoft.com/office/drawing/2014/main" id="{F33C7C13-D549-478F-91C6-F2CC42124A34}"/>
               </a:ext>
             </a:extLst>
           </p:cNvPr>
@@ -2878,7 +2878,7 @@
           <p:cNvPr id="37" name="">
             <a:extLst xmlns:a="http://schemas.openxmlformats.org/drawingml/2006/main">
               <a:ext uri="{FF2B5EF4-FFF2-40B4-BE49-F238E27FC236}">
-                <a16:creationId xmlns:a16="http://schemas.microsoft.com/office/drawing/2014/main" id="{ABBC3163-2AB8-4D7B-B5A4-A1704DC5E249}"/>
+                <a16:creationId xmlns:a16="http://schemas.microsoft.com/office/drawing/2014/main" id="{02473E37-27B8-4C49-9462-15FC7F4BA2A8}"/>
               </a:ext>
             </a:extLst>
           </p:cNvPr>
@@ -2911,7 +2911,7 @@
           <p:cNvPr id="38" name="">
             <a:extLst xmlns:a="http://schemas.openxmlformats.org/drawingml/2006/main">
               <a:ext uri="{FF2B5EF4-FFF2-40B4-BE49-F238E27FC236}">
-                <a16:creationId xmlns:a16="http://schemas.microsoft.com/office/drawing/2014/main" id="{143DE929-84B0-4279-B5C3-B28EBF8352AD}"/>
+                <a16:creationId xmlns:a16="http://schemas.microsoft.com/office/drawing/2014/main" id="{68B5CC97-E3B4-4ADA-8BCD-555E3397DC81}"/>
               </a:ext>
             </a:extLst>
           </p:cNvPr>
@@ -2946,7 +2946,7 @@
           <p:cNvPr id="39" name="">
             <a:extLst xmlns:a="http://schemas.openxmlformats.org/drawingml/2006/main">
               <a:ext uri="{FF2B5EF4-FFF2-40B4-BE49-F238E27FC236}">
-                <a16:creationId xmlns:a16="http://schemas.microsoft.com/office/drawing/2014/main" id="{7E0D7257-E1DC-4FDE-98E1-6D8C4255B5E9}"/>
+                <a16:creationId xmlns:a16="http://schemas.microsoft.com/office/drawing/2014/main" id="{F2EE2760-1199-4072-AEFD-6CB9EF65F50C}"/>
               </a:ext>
             </a:extLst>
           </p:cNvPr>
@@ -3010,7 +3010,7 @@
           <p:cNvPr id="40" name="">
             <a:extLst xmlns:a="http://schemas.openxmlformats.org/drawingml/2006/main">
               <a:ext uri="{FF2B5EF4-FFF2-40B4-BE49-F238E27FC236}">
-                <a16:creationId xmlns:a16="http://schemas.microsoft.com/office/drawing/2014/main" id="{3FC9D94D-7093-4268-B7B8-AD45F0CA5EA0}"/>
+                <a16:creationId xmlns:a16="http://schemas.microsoft.com/office/drawing/2014/main" id="{C517836B-1215-4F74-953D-6E003631C942}"/>
               </a:ext>
             </a:extLst>
           </p:cNvPr>
@@ -3074,7 +3074,7 @@
           <p:cNvPr id="41" name="">
             <a:extLst xmlns:a="http://schemas.openxmlformats.org/drawingml/2006/main">
               <a:ext uri="{FF2B5EF4-FFF2-40B4-BE49-F238E27FC236}">
-                <a16:creationId xmlns:a16="http://schemas.microsoft.com/office/drawing/2014/main" id="{0D9598FD-2574-4E42-BD5F-718750C7116C}"/>
+                <a16:creationId xmlns:a16="http://schemas.microsoft.com/office/drawing/2014/main" id="{2CC8FA74-2D85-4E58-B318-72F3A84119DD}"/>
               </a:ext>
             </a:extLst>
           </p:cNvPr>
@@ -3138,7 +3138,7 @@
           <p:cNvPr id="42" name="">
             <a:extLst xmlns:a="http://schemas.openxmlformats.org/drawingml/2006/main">
               <a:ext uri="{FF2B5EF4-FFF2-40B4-BE49-F238E27FC236}">
-                <a16:creationId xmlns:a16="http://schemas.microsoft.com/office/drawing/2014/main" id="{D7CE585C-6D7F-4A76-9BB1-3F36861B219A}"/>
+                <a16:creationId xmlns:a16="http://schemas.microsoft.com/office/drawing/2014/main" id="{E0A486D8-ED2C-4E4B-B662-48F87C6E517F}"/>
               </a:ext>
             </a:extLst>
           </p:cNvPr>
@@ -3202,7 +3202,7 @@
           <p:cNvPr id="43" name="">
             <a:extLst xmlns:a="http://schemas.openxmlformats.org/drawingml/2006/main">
               <a:ext uri="{FF2B5EF4-FFF2-40B4-BE49-F238E27FC236}">
-                <a16:creationId xmlns:a16="http://schemas.microsoft.com/office/drawing/2014/main" id="{A80065F2-081E-430D-AAA0-D442AD145D5E}"/>
+                <a16:creationId xmlns:a16="http://schemas.microsoft.com/office/drawing/2014/main" id="{130973D9-E2E9-439A-A5A3-69713E01C519}"/>
               </a:ext>
             </a:extLst>
           </p:cNvPr>
@@ -3264,7 +3264,7 @@
     </p:spTree>
     <p:extLst>
       <p:ext uri="{BB962C8B-B14F-4D97-AF65-F5344CB8AC3E}">
-        <p14:creationId xmlns:p14="http://schemas.microsoft.com/office/powerpoint/2010/main" val="1263281242"/>
+        <p14:creationId xmlns:p14="http://schemas.microsoft.com/office/powerpoint/2010/main" val="1767225422"/>
       </p:ext>
     </p:extLst>
   </p:cSld>
@@ -3288,7 +3288,7 @@
           <p:cNvPr id="1" name="">
             <a:extLst xmlns:a="http://schemas.openxmlformats.org/drawingml/2006/main">
               <a:ext uri="{FF2B5EF4-FFF2-40B4-BE49-F238E27FC236}">
-                <a16:creationId xmlns:a16="http://schemas.microsoft.com/office/drawing/2014/main" id="{3A96D427-7302-42D1-9A8A-D6AE9A93D802}"/>
+                <a16:creationId xmlns:a16="http://schemas.microsoft.com/office/drawing/2014/main" id="{D933AB78-A495-4EA3-BA7E-CD916A1509BB}"/>
               </a:ext>
             </a:extLst>
           </p:cNvPr>
@@ -3323,7 +3323,7 @@
           <p:cNvPr id="2" name="">
             <a:extLst xmlns:a="http://schemas.openxmlformats.org/drawingml/2006/main">
               <a:ext uri="{FF2B5EF4-FFF2-40B4-BE49-F238E27FC236}">
-                <a16:creationId xmlns:a16="http://schemas.microsoft.com/office/drawing/2014/main" id="{9488C410-7892-4326-998C-80A3D432D118}"/>
+                <a16:creationId xmlns:a16="http://schemas.microsoft.com/office/drawing/2014/main" id="{3B321529-37B3-4256-BFF2-DADFAC2C86DD}"/>
               </a:ext>
             </a:extLst>
           </p:cNvPr>
@@ -3358,7 +3358,7 @@
           <p:cNvPr id="3" name="">
             <a:extLst xmlns:a="http://schemas.openxmlformats.org/drawingml/2006/main">
               <a:ext uri="{FF2B5EF4-FFF2-40B4-BE49-F238E27FC236}">
-                <a16:creationId xmlns:a16="http://schemas.microsoft.com/office/drawing/2014/main" id="{CC2ED286-DB57-4633-99E9-FB3893333A77}"/>
+                <a16:creationId xmlns:a16="http://schemas.microsoft.com/office/drawing/2014/main" id="{2438FC9D-8FD4-477B-AB07-55ED18694A44}"/>
               </a:ext>
             </a:extLst>
           </p:cNvPr>
@@ -3422,7 +3422,7 @@
           <p:cNvPr id="4" name="">
             <a:extLst xmlns:a="http://schemas.openxmlformats.org/drawingml/2006/main">
               <a:ext uri="{FF2B5EF4-FFF2-40B4-BE49-F238E27FC236}">
-                <a16:creationId xmlns:a16="http://schemas.microsoft.com/office/drawing/2014/main" id="{B19C03CD-A969-4DE4-BE3D-4C7956893C15}"/>
+                <a16:creationId xmlns:a16="http://schemas.microsoft.com/office/drawing/2014/main" id="{A1F6A4F4-3435-4F66-9710-3EA5B203A063}"/>
               </a:ext>
             </a:extLst>
           </p:cNvPr>
@@ -3486,7 +3486,7 @@
           <p:cNvPr id="5" name="">
             <a:extLst xmlns:a="http://schemas.openxmlformats.org/drawingml/2006/main">
               <a:ext uri="{FF2B5EF4-FFF2-40B4-BE49-F238E27FC236}">
-                <a16:creationId xmlns:a16="http://schemas.microsoft.com/office/drawing/2014/main" id="{A42ED076-3F3A-4DCB-ADC9-48036F28F537}"/>
+                <a16:creationId xmlns:a16="http://schemas.microsoft.com/office/drawing/2014/main" id="{AF16E97C-C4AF-4CCB-9FDA-8171C167352B}"/>
               </a:ext>
             </a:extLst>
           </p:cNvPr>
@@ -3540,7 +3540,7 @@
                 <a:ea typeface="Aptos"/>
                 <a:cs typeface="Aptos"/>
               </a:rPr>
-              <a:t>Banks, insurers, and healthcare teams may need open-weight agents for cost, compliance, and data sovereignty. The risk is losing frontier-lab-style safety observability once the model is self-hosted.</a:t>
+              <a:t>Regulated teams in finance, healthcare, insurance, public-sector, and internal operations may need open-weight agents for cost, compliance, and data sovereignty. The risk is losing frontier-lab-style safety observability once the model is self-hosted.</a:t>
             </a:r>
           </a:p>
         </p:txBody>
@@ -3550,7 +3550,7 @@
           <p:cNvPr id="6" name="">
             <a:extLst xmlns:a="http://schemas.openxmlformats.org/drawingml/2006/main">
               <a:ext uri="{FF2B5EF4-FFF2-40B4-BE49-F238E27FC236}">
-                <a16:creationId xmlns:a16="http://schemas.microsoft.com/office/drawing/2014/main" id="{FD7C2C90-6F29-4B5D-BC6E-C04364819118}"/>
+                <a16:creationId xmlns:a16="http://schemas.microsoft.com/office/drawing/2014/main" id="{9D07E272-128B-418E-AD62-854C63DC9239}"/>
               </a:ext>
             </a:extLst>
           </p:cNvPr>
@@ -3583,7 +3583,7 @@
           <p:cNvPr id="7" name="">
             <a:extLst xmlns:a="http://schemas.openxmlformats.org/drawingml/2006/main">
               <a:ext uri="{FF2B5EF4-FFF2-40B4-BE49-F238E27FC236}">
-                <a16:creationId xmlns:a16="http://schemas.microsoft.com/office/drawing/2014/main" id="{462ECAA2-7C7F-4EE1-A4E9-A29347F17591}"/>
+                <a16:creationId xmlns:a16="http://schemas.microsoft.com/office/drawing/2014/main" id="{43EC376B-EDCB-4840-81F7-7EB09405FDA8}"/>
               </a:ext>
             </a:extLst>
           </p:cNvPr>
@@ -3647,7 +3647,7 @@
           <p:cNvPr id="8" name="">
             <a:extLst xmlns:a="http://schemas.openxmlformats.org/drawingml/2006/main">
               <a:ext uri="{FF2B5EF4-FFF2-40B4-BE49-F238E27FC236}">
-                <a16:creationId xmlns:a16="http://schemas.microsoft.com/office/drawing/2014/main" id="{D9C26BCD-5710-4A88-BB0F-4831D3F5A709}"/>
+                <a16:creationId xmlns:a16="http://schemas.microsoft.com/office/drawing/2014/main" id="{3C63D3F4-791B-4013-8B0C-C4BE6C6E9DC4}"/>
               </a:ext>
             </a:extLst>
           </p:cNvPr>
@@ -3711,7 +3711,7 @@
           <p:cNvPr id="9" name="">
             <a:extLst xmlns:a="http://schemas.openxmlformats.org/drawingml/2006/main">
               <a:ext uri="{FF2B5EF4-FFF2-40B4-BE49-F238E27FC236}">
-                <a16:creationId xmlns:a16="http://schemas.microsoft.com/office/drawing/2014/main" id="{CE93516A-9AD2-48BB-BBDF-B3809A1B3CAC}"/>
+                <a16:creationId xmlns:a16="http://schemas.microsoft.com/office/drawing/2014/main" id="{C0C7B79D-A0F3-4A14-AC01-189E613E5E7E}"/>
               </a:ext>
             </a:extLst>
           </p:cNvPr>
@@ -3744,7 +3744,7 @@
           <p:cNvPr id="10" name="">
             <a:extLst xmlns:a="http://schemas.openxmlformats.org/drawingml/2006/main">
               <a:ext uri="{FF2B5EF4-FFF2-40B4-BE49-F238E27FC236}">
-                <a16:creationId xmlns:a16="http://schemas.microsoft.com/office/drawing/2014/main" id="{1663DF1B-4FE0-45C0-BB13-F1280AB79A28}"/>
+                <a16:creationId xmlns:a16="http://schemas.microsoft.com/office/drawing/2014/main" id="{FB84069D-2F71-49BA-9D77-C6AFE72B2B1B}"/>
               </a:ext>
             </a:extLst>
           </p:cNvPr>
@@ -3808,7 +3808,7 @@
           <p:cNvPr id="11" name="">
             <a:extLst xmlns:a="http://schemas.openxmlformats.org/drawingml/2006/main">
               <a:ext uri="{FF2B5EF4-FFF2-40B4-BE49-F238E27FC236}">
-                <a16:creationId xmlns:a16="http://schemas.microsoft.com/office/drawing/2014/main" id="{A0B555F8-28E9-40F0-B671-1D3D0EFDDE2D}"/>
+                <a16:creationId xmlns:a16="http://schemas.microsoft.com/office/drawing/2014/main" id="{1829C89D-3909-4988-94F2-0BB708F481F3}"/>
               </a:ext>
             </a:extLst>
           </p:cNvPr>
@@ -3872,7 +3872,7 @@
           <p:cNvPr id="12" name="">
             <a:extLst xmlns:a="http://schemas.openxmlformats.org/drawingml/2006/main">
               <a:ext uri="{FF2B5EF4-FFF2-40B4-BE49-F238E27FC236}">
-                <a16:creationId xmlns:a16="http://schemas.microsoft.com/office/drawing/2014/main" id="{BE1F4CE8-6FD7-418E-87F6-15F1A1FCD92B}"/>
+                <a16:creationId xmlns:a16="http://schemas.microsoft.com/office/drawing/2014/main" id="{F1EFB102-DA27-4E40-9B44-59D8EF44D30E}"/>
               </a:ext>
             </a:extLst>
           </p:cNvPr>
@@ -3905,7 +3905,7 @@
           <p:cNvPr id="13" name="">
             <a:extLst xmlns:a="http://schemas.openxmlformats.org/drawingml/2006/main">
               <a:ext uri="{FF2B5EF4-FFF2-40B4-BE49-F238E27FC236}">
-                <a16:creationId xmlns:a16="http://schemas.microsoft.com/office/drawing/2014/main" id="{F9430762-F194-4943-A65D-91303241C51A}"/>
+                <a16:creationId xmlns:a16="http://schemas.microsoft.com/office/drawing/2014/main" id="{6F70D212-4674-491F-937F-A140BD81F60F}"/>
               </a:ext>
             </a:extLst>
           </p:cNvPr>
@@ -3969,7 +3969,7 @@
           <p:cNvPr id="14" name="">
             <a:extLst xmlns:a="http://schemas.openxmlformats.org/drawingml/2006/main">
               <a:ext uri="{FF2B5EF4-FFF2-40B4-BE49-F238E27FC236}">
-                <a16:creationId xmlns:a16="http://schemas.microsoft.com/office/drawing/2014/main" id="{BAB9E229-D703-4788-8FB7-5292B740C987}"/>
+                <a16:creationId xmlns:a16="http://schemas.microsoft.com/office/drawing/2014/main" id="{13DC453F-5B1B-4818-8ED4-29FE256B10E3}"/>
               </a:ext>
             </a:extLst>
           </p:cNvPr>
@@ -4033,7 +4033,7 @@
           <p:cNvPr id="15" name="">
             <a:extLst xmlns:a="http://schemas.openxmlformats.org/drawingml/2006/main">
               <a:ext uri="{FF2B5EF4-FFF2-40B4-BE49-F238E27FC236}">
-                <a16:creationId xmlns:a16="http://schemas.microsoft.com/office/drawing/2014/main" id="{43485B47-3AD4-472F-A333-34ABD3137C9C}"/>
+                <a16:creationId xmlns:a16="http://schemas.microsoft.com/office/drawing/2014/main" id="{D9AA8791-167B-42A5-A72A-9C0D9193AC86}"/>
               </a:ext>
             </a:extLst>
           </p:cNvPr>
@@ -4068,7 +4068,7 @@
           <p:cNvPr id="16" name="">
             <a:extLst xmlns:a="http://schemas.openxmlformats.org/drawingml/2006/main">
               <a:ext uri="{FF2B5EF4-FFF2-40B4-BE49-F238E27FC236}">
-                <a16:creationId xmlns:a16="http://schemas.microsoft.com/office/drawing/2014/main" id="{12462C06-2349-4D08-BBB3-1DD1ABA153CF}"/>
+                <a16:creationId xmlns:a16="http://schemas.microsoft.com/office/drawing/2014/main" id="{F1CDA241-5EE2-4E28-8205-4603E5AA409F}"/>
               </a:ext>
             </a:extLst>
           </p:cNvPr>
@@ -4103,7 +4103,7 @@
           <p:cNvPr id="17" name="">
             <a:extLst xmlns:a="http://schemas.openxmlformats.org/drawingml/2006/main">
               <a:ext uri="{FF2B5EF4-FFF2-40B4-BE49-F238E27FC236}">
-                <a16:creationId xmlns:a16="http://schemas.microsoft.com/office/drawing/2014/main" id="{53659685-E6C6-47D6-9971-86EE8324453C}"/>
+                <a16:creationId xmlns:a16="http://schemas.microsoft.com/office/drawing/2014/main" id="{2E72D145-3865-4297-A103-1F4C7B4630AB}"/>
               </a:ext>
             </a:extLst>
           </p:cNvPr>
@@ -4138,7 +4138,7 @@
           <p:cNvPr id="18" name="">
             <a:extLst xmlns:a="http://schemas.openxmlformats.org/drawingml/2006/main">
               <a:ext uri="{FF2B5EF4-FFF2-40B4-BE49-F238E27FC236}">
-                <a16:creationId xmlns:a16="http://schemas.microsoft.com/office/drawing/2014/main" id="{78D8F799-D316-4C00-B5A9-7D15470A200B}"/>
+                <a16:creationId xmlns:a16="http://schemas.microsoft.com/office/drawing/2014/main" id="{B5D79769-02EE-4232-9612-E6263861D877}"/>
               </a:ext>
             </a:extLst>
           </p:cNvPr>
@@ -4173,7 +4173,7 @@
           <p:cNvPr id="19" name="">
             <a:extLst xmlns:a="http://schemas.openxmlformats.org/drawingml/2006/main">
               <a:ext uri="{FF2B5EF4-FFF2-40B4-BE49-F238E27FC236}">
-                <a16:creationId xmlns:a16="http://schemas.microsoft.com/office/drawing/2014/main" id="{F89C7EA0-ACBD-40F3-9A78-42DB2EAC544F}"/>
+                <a16:creationId xmlns:a16="http://schemas.microsoft.com/office/drawing/2014/main" id="{69C4A120-8114-4F79-8189-2C1EEE2A2400}"/>
               </a:ext>
             </a:extLst>
           </p:cNvPr>
@@ -4208,7 +4208,7 @@
           <p:cNvPr id="20" name="">
             <a:extLst xmlns:a="http://schemas.openxmlformats.org/drawingml/2006/main">
               <a:ext uri="{FF2B5EF4-FFF2-40B4-BE49-F238E27FC236}">
-                <a16:creationId xmlns:a16="http://schemas.microsoft.com/office/drawing/2014/main" id="{1423036B-2404-45E1-B5EF-595A82FFCFBE}"/>
+                <a16:creationId xmlns:a16="http://schemas.microsoft.com/office/drawing/2014/main" id="{0B50F03D-2189-4889-AF8D-184F32A694E4}"/>
               </a:ext>
             </a:extLst>
           </p:cNvPr>
@@ -4272,7 +4272,7 @@
           <p:cNvPr id="21" name="">
             <a:extLst xmlns:a="http://schemas.openxmlformats.org/drawingml/2006/main">
               <a:ext uri="{FF2B5EF4-FFF2-40B4-BE49-F238E27FC236}">
-                <a16:creationId xmlns:a16="http://schemas.microsoft.com/office/drawing/2014/main" id="{556D1749-4C91-4137-8467-1BB18E383D43}"/>
+                <a16:creationId xmlns:a16="http://schemas.microsoft.com/office/drawing/2014/main" id="{8E116B7D-4C36-413E-B3E6-609D799A0984}"/>
               </a:ext>
             </a:extLst>
           </p:cNvPr>
@@ -4307,7 +4307,7 @@
           <p:cNvPr id="22" name="">
             <a:extLst xmlns:a="http://schemas.openxmlformats.org/drawingml/2006/main">
               <a:ext uri="{FF2B5EF4-FFF2-40B4-BE49-F238E27FC236}">
-                <a16:creationId xmlns:a16="http://schemas.microsoft.com/office/drawing/2014/main" id="{A1CC6E80-2B91-47E7-A5CC-0F92C6690D31}"/>
+                <a16:creationId xmlns:a16="http://schemas.microsoft.com/office/drawing/2014/main" id="{2C1E7345-AEBB-4D59-B32D-BDA1ADE7B33F}"/>
               </a:ext>
             </a:extLst>
           </p:cNvPr>
@@ -4371,7 +4371,7 @@
           <p:cNvPr id="23" name="">
             <a:extLst xmlns:a="http://schemas.openxmlformats.org/drawingml/2006/main">
               <a:ext uri="{FF2B5EF4-FFF2-40B4-BE49-F238E27FC236}">
-                <a16:creationId xmlns:a16="http://schemas.microsoft.com/office/drawing/2014/main" id="{76E4A2F5-982E-4AB9-87DC-BB890BA9AFEA}"/>
+                <a16:creationId xmlns:a16="http://schemas.microsoft.com/office/drawing/2014/main" id="{8E83F9CD-8012-4BAC-B314-26E41627948C}"/>
               </a:ext>
             </a:extLst>
           </p:cNvPr>
@@ -4406,7 +4406,7 @@
           <p:cNvPr id="24" name="">
             <a:extLst xmlns:a="http://schemas.openxmlformats.org/drawingml/2006/main">
               <a:ext uri="{FF2B5EF4-FFF2-40B4-BE49-F238E27FC236}">
-                <a16:creationId xmlns:a16="http://schemas.microsoft.com/office/drawing/2014/main" id="{AF99CAE8-5BDB-4150-A409-0CF3F467D35B}"/>
+                <a16:creationId xmlns:a16="http://schemas.microsoft.com/office/drawing/2014/main" id="{EA9026D8-3DA3-429E-A50B-4FD6E16D3BAB}"/>
               </a:ext>
             </a:extLst>
           </p:cNvPr>
@@ -4470,7 +4470,7 @@
           <p:cNvPr id="25" name="">
             <a:extLst xmlns:a="http://schemas.openxmlformats.org/drawingml/2006/main">
               <a:ext uri="{FF2B5EF4-FFF2-40B4-BE49-F238E27FC236}">
-                <a16:creationId xmlns:a16="http://schemas.microsoft.com/office/drawing/2014/main" id="{66B4C5A0-B695-4A9A-B1A2-8A5F310CCDE4}"/>
+                <a16:creationId xmlns:a16="http://schemas.microsoft.com/office/drawing/2014/main" id="{D7DEC620-5AF6-4F76-93C1-38B964EC9390}"/>
               </a:ext>
             </a:extLst>
           </p:cNvPr>
@@ -4505,7 +4505,7 @@
           <p:cNvPr id="26" name="">
             <a:extLst xmlns:a="http://schemas.openxmlformats.org/drawingml/2006/main">
               <a:ext uri="{FF2B5EF4-FFF2-40B4-BE49-F238E27FC236}">
-                <a16:creationId xmlns:a16="http://schemas.microsoft.com/office/drawing/2014/main" id="{8E39DDBA-74B5-4927-89E7-B9100DEBE13F}"/>
+                <a16:creationId xmlns:a16="http://schemas.microsoft.com/office/drawing/2014/main" id="{E0D33D37-6676-4C88-853E-68F758BAA5E8}"/>
               </a:ext>
             </a:extLst>
           </p:cNvPr>
@@ -4569,7 +4569,7 @@
           <p:cNvPr id="27" name="">
             <a:extLst xmlns:a="http://schemas.openxmlformats.org/drawingml/2006/main">
               <a:ext uri="{FF2B5EF4-FFF2-40B4-BE49-F238E27FC236}">
-                <a16:creationId xmlns:a16="http://schemas.microsoft.com/office/drawing/2014/main" id="{6B5164D5-577F-400A-97E8-04BFF8F324B0}"/>
+                <a16:creationId xmlns:a16="http://schemas.microsoft.com/office/drawing/2014/main" id="{531FC1D9-723A-44E6-87F8-233C6199B1F9}"/>
               </a:ext>
             </a:extLst>
           </p:cNvPr>
@@ -4604,7 +4604,7 @@
           <p:cNvPr id="28" name="">
             <a:extLst xmlns:a="http://schemas.openxmlformats.org/drawingml/2006/main">
               <a:ext uri="{FF2B5EF4-FFF2-40B4-BE49-F238E27FC236}">
-                <a16:creationId xmlns:a16="http://schemas.microsoft.com/office/drawing/2014/main" id="{A7F37A32-CB46-4FC1-87EF-13FAE5D270D7}"/>
+                <a16:creationId xmlns:a16="http://schemas.microsoft.com/office/drawing/2014/main" id="{FB7C74AD-EA19-4FD7-B1F3-48D4736DA960}"/>
               </a:ext>
             </a:extLst>
           </p:cNvPr>
@@ -4668,7 +4668,7 @@
           <p:cNvPr id="29" name="">
             <a:extLst xmlns:a="http://schemas.openxmlformats.org/drawingml/2006/main">
               <a:ext uri="{FF2B5EF4-FFF2-40B4-BE49-F238E27FC236}">
-                <a16:creationId xmlns:a16="http://schemas.microsoft.com/office/drawing/2014/main" id="{8DF26258-5165-430D-91E9-02F0ECC081FA}"/>
+                <a16:creationId xmlns:a16="http://schemas.microsoft.com/office/drawing/2014/main" id="{B0A31468-DF3A-46FC-BA1B-86263D08202A}"/>
               </a:ext>
             </a:extLst>
           </p:cNvPr>
@@ -4732,7 +4732,7 @@
           <p:cNvPr id="30" name="">
             <a:extLst xmlns:a="http://schemas.openxmlformats.org/drawingml/2006/main">
               <a:ext uri="{FF2B5EF4-FFF2-40B4-BE49-F238E27FC236}">
-                <a16:creationId xmlns:a16="http://schemas.microsoft.com/office/drawing/2014/main" id="{FE18D122-89FC-4177-B09B-8EC92231D019}"/>
+                <a16:creationId xmlns:a16="http://schemas.microsoft.com/office/drawing/2014/main" id="{4E3C411C-C977-4CEE-AE50-DE42180DF066}"/>
               </a:ext>
             </a:extLst>
           </p:cNvPr>
@@ -4767,7 +4767,7 @@
           <p:cNvPr id="31" name="">
             <a:extLst xmlns:a="http://schemas.openxmlformats.org/drawingml/2006/main">
               <a:ext uri="{FF2B5EF4-FFF2-40B4-BE49-F238E27FC236}">
-                <a16:creationId xmlns:a16="http://schemas.microsoft.com/office/drawing/2014/main" id="{9B420AEE-DB58-4F44-A1D3-603DA4E5C062}"/>
+                <a16:creationId xmlns:a16="http://schemas.microsoft.com/office/drawing/2014/main" id="{B4DA3F93-DA7C-49D6-9C50-82488A6A3802}"/>
               </a:ext>
             </a:extLst>
           </p:cNvPr>
@@ -4831,7 +4831,7 @@
           <p:cNvPr id="32" name="">
             <a:extLst xmlns:a="http://schemas.openxmlformats.org/drawingml/2006/main">
               <a:ext uri="{FF2B5EF4-FFF2-40B4-BE49-F238E27FC236}">
-                <a16:creationId xmlns:a16="http://schemas.microsoft.com/office/drawing/2014/main" id="{675A066A-DDB8-43C4-9FAB-91167A154226}"/>
+                <a16:creationId xmlns:a16="http://schemas.microsoft.com/office/drawing/2014/main" id="{F095017B-C10D-48DB-80F8-8AEC0414E734}"/>
               </a:ext>
             </a:extLst>
           </p:cNvPr>
@@ -4895,7 +4895,7 @@
           <p:cNvPr id="33" name="">
             <a:extLst xmlns:a="http://schemas.openxmlformats.org/drawingml/2006/main">
               <a:ext uri="{FF2B5EF4-FFF2-40B4-BE49-F238E27FC236}">
-                <a16:creationId xmlns:a16="http://schemas.microsoft.com/office/drawing/2014/main" id="{CEBA7984-31C5-4ED7-BF4C-A4FBBC46133C}"/>
+                <a16:creationId xmlns:a16="http://schemas.microsoft.com/office/drawing/2014/main" id="{166EE4BD-5958-4C4E-9FE0-97AE045A1FFD}"/>
               </a:ext>
             </a:extLst>
           </p:cNvPr>
@@ -4930,7 +4930,7 @@
           <p:cNvPr id="34" name="">
             <a:extLst xmlns:a="http://schemas.openxmlformats.org/drawingml/2006/main">
               <a:ext uri="{FF2B5EF4-FFF2-40B4-BE49-F238E27FC236}">
-                <a16:creationId xmlns:a16="http://schemas.microsoft.com/office/drawing/2014/main" id="{1B10EC28-CF21-44AE-9965-967A42B0D511}"/>
+                <a16:creationId xmlns:a16="http://schemas.microsoft.com/office/drawing/2014/main" id="{261192BE-9DE8-44FC-81AC-5FBCB7057436}"/>
               </a:ext>
             </a:extLst>
           </p:cNvPr>
@@ -4994,7 +4994,7 @@
           <p:cNvPr id="35" name="">
             <a:extLst xmlns:a="http://schemas.openxmlformats.org/drawingml/2006/main">
               <a:ext uri="{FF2B5EF4-FFF2-40B4-BE49-F238E27FC236}">
-                <a16:creationId xmlns:a16="http://schemas.microsoft.com/office/drawing/2014/main" id="{E8FEE2CE-7DC6-4FB6-88C0-1E313A7BCD5C}"/>
+                <a16:creationId xmlns:a16="http://schemas.microsoft.com/office/drawing/2014/main" id="{ACF51498-7328-441A-A109-5CE2D8A7735D}"/>
               </a:ext>
             </a:extLst>
           </p:cNvPr>
@@ -5058,7 +5058,7 @@
           <p:cNvPr id="36" name="">
             <a:extLst xmlns:a="http://schemas.openxmlformats.org/drawingml/2006/main">
               <a:ext uri="{FF2B5EF4-FFF2-40B4-BE49-F238E27FC236}">
-                <a16:creationId xmlns:a16="http://schemas.microsoft.com/office/drawing/2014/main" id="{0D93DDF3-C301-4C9B-98E3-9059C74D2B2D}"/>
+                <a16:creationId xmlns:a16="http://schemas.microsoft.com/office/drawing/2014/main" id="{606685CF-6125-493F-9EA9-6F47D4C617DB}"/>
               </a:ext>
             </a:extLst>
           </p:cNvPr>
@@ -5093,7 +5093,7 @@
           <p:cNvPr id="37" name="">
             <a:extLst xmlns:a="http://schemas.openxmlformats.org/drawingml/2006/main">
               <a:ext uri="{FF2B5EF4-FFF2-40B4-BE49-F238E27FC236}">
-                <a16:creationId xmlns:a16="http://schemas.microsoft.com/office/drawing/2014/main" id="{E05EC774-8DAB-442C-B4E8-FA2936F76331}"/>
+                <a16:creationId xmlns:a16="http://schemas.microsoft.com/office/drawing/2014/main" id="{D55CD0D4-AFB5-4FE5-B5C5-E581A1B2AAF1}"/>
               </a:ext>
             </a:extLst>
           </p:cNvPr>
@@ -5157,7 +5157,7 @@
           <p:cNvPr id="38" name="">
             <a:extLst xmlns:a="http://schemas.openxmlformats.org/drawingml/2006/main">
               <a:ext uri="{FF2B5EF4-FFF2-40B4-BE49-F238E27FC236}">
-                <a16:creationId xmlns:a16="http://schemas.microsoft.com/office/drawing/2014/main" id="{D0021648-DB92-42E2-93CD-3B75D0221321}"/>
+                <a16:creationId xmlns:a16="http://schemas.microsoft.com/office/drawing/2014/main" id="{A6DAE5F1-CDFA-451A-954D-55DDB751DC96}"/>
               </a:ext>
             </a:extLst>
           </p:cNvPr>
@@ -5221,7 +5221,7 @@
           <p:cNvPr id="39" name="">
             <a:extLst xmlns:a="http://schemas.openxmlformats.org/drawingml/2006/main">
               <a:ext uri="{FF2B5EF4-FFF2-40B4-BE49-F238E27FC236}">
-                <a16:creationId xmlns:a16="http://schemas.microsoft.com/office/drawing/2014/main" id="{6ED17A50-B058-4347-BF9F-398AB48D9927}"/>
+                <a16:creationId xmlns:a16="http://schemas.microsoft.com/office/drawing/2014/main" id="{D19CB31A-CA65-4AE2-ADF9-39FF7CC67602}"/>
               </a:ext>
             </a:extLst>
           </p:cNvPr>
@@ -5256,7 +5256,7 @@
           <p:cNvPr id="40" name="">
             <a:extLst xmlns:a="http://schemas.openxmlformats.org/drawingml/2006/main">
               <a:ext uri="{FF2B5EF4-FFF2-40B4-BE49-F238E27FC236}">
-                <a16:creationId xmlns:a16="http://schemas.microsoft.com/office/drawing/2014/main" id="{9DC9C943-234B-422A-8B0C-7554D5365A2D}"/>
+                <a16:creationId xmlns:a16="http://schemas.microsoft.com/office/drawing/2014/main" id="{468913E6-0507-45C8-B00B-8375AD35B5D1}"/>
               </a:ext>
             </a:extLst>
           </p:cNvPr>
@@ -5320,7 +5320,7 @@
           <p:cNvPr id="41" name="">
             <a:extLst xmlns:a="http://schemas.openxmlformats.org/drawingml/2006/main">
               <a:ext uri="{FF2B5EF4-FFF2-40B4-BE49-F238E27FC236}">
-                <a16:creationId xmlns:a16="http://schemas.microsoft.com/office/drawing/2014/main" id="{415520F8-5A30-4FF8-836B-A02EF6C64977}"/>
+                <a16:creationId xmlns:a16="http://schemas.microsoft.com/office/drawing/2014/main" id="{74E7ED8C-2D19-4622-9AD6-C37E0CE7E18C}"/>
               </a:ext>
             </a:extLst>
           </p:cNvPr>
@@ -5384,7 +5384,7 @@
           <p:cNvPr id="42" name="">
             <a:extLst xmlns:a="http://schemas.openxmlformats.org/drawingml/2006/main">
               <a:ext uri="{FF2B5EF4-FFF2-40B4-BE49-F238E27FC236}">
-                <a16:creationId xmlns:a16="http://schemas.microsoft.com/office/drawing/2014/main" id="{A9CFB849-55AE-4E47-9746-FEA92A090755}"/>
+                <a16:creationId xmlns:a16="http://schemas.microsoft.com/office/drawing/2014/main" id="{DEAFD269-99BC-4F0E-B1EC-1E5BA3367A8F}"/>
               </a:ext>
             </a:extLst>
           </p:cNvPr>
@@ -5448,7 +5448,7 @@
           <p:cNvPr id="43" name="">
             <a:extLst xmlns:a="http://schemas.openxmlformats.org/drawingml/2006/main">
               <a:ext uri="{FF2B5EF4-FFF2-40B4-BE49-F238E27FC236}">
-                <a16:creationId xmlns:a16="http://schemas.microsoft.com/office/drawing/2014/main" id="{44496DC6-29E0-4924-A6B6-8E16D816583D}"/>
+                <a16:creationId xmlns:a16="http://schemas.microsoft.com/office/drawing/2014/main" id="{96796CE6-710E-457F-80D3-F1514A7D3B28}"/>
               </a:ext>
             </a:extLst>
           </p:cNvPr>
@@ -5510,7 +5510,7 @@
     </p:spTree>
     <p:extLst>
       <p:ext uri="{BB962C8B-B14F-4D97-AF65-F5344CB8AC3E}">
-        <p14:creationId xmlns:p14="http://schemas.microsoft.com/office/powerpoint/2010/main" val="1721895214"/>
+        <p14:creationId xmlns:p14="http://schemas.microsoft.com/office/powerpoint/2010/main" val="1654837692"/>
       </p:ext>
     </p:extLst>
   </p:cSld>
@@ -5534,7 +5534,7 @@
           <p:cNvPr id="1" name="">
             <a:extLst xmlns:a="http://schemas.openxmlformats.org/drawingml/2006/main">
               <a:ext uri="{FF2B5EF4-FFF2-40B4-BE49-F238E27FC236}">
-                <a16:creationId xmlns:a16="http://schemas.microsoft.com/office/drawing/2014/main" id="{153D9201-E7CE-4041-929B-3141CC083857}"/>
+                <a16:creationId xmlns:a16="http://schemas.microsoft.com/office/drawing/2014/main" id="{86909E99-B4B9-4D5A-8C7E-FCA603509AE3}"/>
               </a:ext>
             </a:extLst>
           </p:cNvPr>
@@ -5569,7 +5569,7 @@
           <p:cNvPr id="2" name="">
             <a:extLst xmlns:a="http://schemas.openxmlformats.org/drawingml/2006/main">
               <a:ext uri="{FF2B5EF4-FFF2-40B4-BE49-F238E27FC236}">
-                <a16:creationId xmlns:a16="http://schemas.microsoft.com/office/drawing/2014/main" id="{CC8E4E1D-F405-46FB-8DFC-DD76B50E0A95}"/>
+                <a16:creationId xmlns:a16="http://schemas.microsoft.com/office/drawing/2014/main" id="{8D347EB2-55AB-46E7-A6D8-32E3E9AB89BA}"/>
               </a:ext>
             </a:extLst>
           </p:cNvPr>
@@ -5604,7 +5604,7 @@
           <p:cNvPr id="3" name="">
             <a:extLst xmlns:a="http://schemas.openxmlformats.org/drawingml/2006/main">
               <a:ext uri="{FF2B5EF4-FFF2-40B4-BE49-F238E27FC236}">
-                <a16:creationId xmlns:a16="http://schemas.microsoft.com/office/drawing/2014/main" id="{66D94498-84CB-4797-BB12-124642EC2A99}"/>
+                <a16:creationId xmlns:a16="http://schemas.microsoft.com/office/drawing/2014/main" id="{72A2B17D-C6EB-4ED7-B69D-4944762457FA}"/>
               </a:ext>
             </a:extLst>
           </p:cNvPr>
@@ -5668,7 +5668,7 @@
           <p:cNvPr id="4" name="">
             <a:extLst xmlns:a="http://schemas.openxmlformats.org/drawingml/2006/main">
               <a:ext uri="{FF2B5EF4-FFF2-40B4-BE49-F238E27FC236}">
-                <a16:creationId xmlns:a16="http://schemas.microsoft.com/office/drawing/2014/main" id="{A60E904D-D01B-422B-867C-6565B594CE9F}"/>
+                <a16:creationId xmlns:a16="http://schemas.microsoft.com/office/drawing/2014/main" id="{7F7785F9-288C-46C3-85A2-055F53C482CF}"/>
               </a:ext>
             </a:extLst>
           </p:cNvPr>
@@ -5732,7 +5732,7 @@
           <p:cNvPr id="5" name="">
             <a:extLst xmlns:a="http://schemas.openxmlformats.org/drawingml/2006/main">
               <a:ext uri="{FF2B5EF4-FFF2-40B4-BE49-F238E27FC236}">
-                <a16:creationId xmlns:a16="http://schemas.microsoft.com/office/drawing/2014/main" id="{791BEE2D-8058-49FD-85A7-C233084818D1}"/>
+                <a16:creationId xmlns:a16="http://schemas.microsoft.com/office/drawing/2014/main" id="{89A9437A-CA8F-4A83-BA94-35A3E3BD2B42}"/>
               </a:ext>
             </a:extLst>
           </p:cNvPr>
@@ -5796,7 +5796,7 @@
           <p:cNvPr id="6" name="">
             <a:extLst xmlns:a="http://schemas.openxmlformats.org/drawingml/2006/main">
               <a:ext uri="{FF2B5EF4-FFF2-40B4-BE49-F238E27FC236}">
-                <a16:creationId xmlns:a16="http://schemas.microsoft.com/office/drawing/2014/main" id="{B95E96AF-A482-41E2-AE0E-7EACD4CD472E}"/>
+                <a16:creationId xmlns:a16="http://schemas.microsoft.com/office/drawing/2014/main" id="{CC9203A1-C1D8-495D-9D81-D561DD20A1B2}"/>
               </a:ext>
             </a:extLst>
           </p:cNvPr>
@@ -5829,7 +5829,7 @@
           <p:cNvPr id="7" name="">
             <a:extLst xmlns:a="http://schemas.openxmlformats.org/drawingml/2006/main">
               <a:ext uri="{FF2B5EF4-FFF2-40B4-BE49-F238E27FC236}">
-                <a16:creationId xmlns:a16="http://schemas.microsoft.com/office/drawing/2014/main" id="{BBA4C649-8B5E-469D-A345-48CA25DF7858}"/>
+                <a16:creationId xmlns:a16="http://schemas.microsoft.com/office/drawing/2014/main" id="{AFA421DC-5FCD-4B57-BCAE-7DB16EAEAA5A}"/>
               </a:ext>
             </a:extLst>
           </p:cNvPr>
@@ -5893,7 +5893,7 @@
           <p:cNvPr id="8" name="">
             <a:extLst xmlns:a="http://schemas.openxmlformats.org/drawingml/2006/main">
               <a:ext uri="{FF2B5EF4-FFF2-40B4-BE49-F238E27FC236}">
-                <a16:creationId xmlns:a16="http://schemas.microsoft.com/office/drawing/2014/main" id="{E70888AA-1DA3-4D0A-9138-DF70A2334830}"/>
+                <a16:creationId xmlns:a16="http://schemas.microsoft.com/office/drawing/2014/main" id="{99F3B1F8-9FC0-4770-9B0C-3617380B6D96}"/>
               </a:ext>
             </a:extLst>
           </p:cNvPr>
@@ -5947,7 +5947,7 @@
                 <a:ea typeface="Aptos"/>
                 <a:cs typeface="Aptos"/>
               </a:rPr>
-              <a:t>`system prompt override` or `unauthorized transfer`</a:t>
+              <a:t>`system prompt override` or `unauthorized action`</a:t>
             </a:r>
           </a:p>
         </p:txBody>
@@ -5957,7 +5957,7 @@
           <p:cNvPr id="9" name="">
             <a:extLst xmlns:a="http://schemas.openxmlformats.org/drawingml/2006/main">
               <a:ext uri="{FF2B5EF4-FFF2-40B4-BE49-F238E27FC236}">
-                <a16:creationId xmlns:a16="http://schemas.microsoft.com/office/drawing/2014/main" id="{CE166468-17FA-40B0-B46E-74D409221A0C}"/>
+                <a16:creationId xmlns:a16="http://schemas.microsoft.com/office/drawing/2014/main" id="{2D2E3D81-B457-4B4D-9D09-3911ECE0C38F}"/>
               </a:ext>
             </a:extLst>
           </p:cNvPr>
@@ -5990,7 +5990,7 @@
           <p:cNvPr id="10" name="">
             <a:extLst xmlns:a="http://schemas.openxmlformats.org/drawingml/2006/main">
               <a:ext uri="{FF2B5EF4-FFF2-40B4-BE49-F238E27FC236}">
-                <a16:creationId xmlns:a16="http://schemas.microsoft.com/office/drawing/2014/main" id="{AF465200-5327-4543-9CD3-070D5DA2692F}"/>
+                <a16:creationId xmlns:a16="http://schemas.microsoft.com/office/drawing/2014/main" id="{D7DDA714-FEA6-409F-B8A7-5206519E036D}"/>
               </a:ext>
             </a:extLst>
           </p:cNvPr>
@@ -6054,7 +6054,7 @@
           <p:cNvPr id="11" name="">
             <a:extLst xmlns:a="http://schemas.openxmlformats.org/drawingml/2006/main">
               <a:ext uri="{FF2B5EF4-FFF2-40B4-BE49-F238E27FC236}">
-                <a16:creationId xmlns:a16="http://schemas.microsoft.com/office/drawing/2014/main" id="{6DB3D95A-9421-41B4-9651-827F207B2249}"/>
+                <a16:creationId xmlns:a16="http://schemas.microsoft.com/office/drawing/2014/main" id="{F3DA4A14-049D-4C45-A5D9-396C5076E8AD}"/>
               </a:ext>
             </a:extLst>
           </p:cNvPr>
@@ -6118,7 +6118,7 @@
           <p:cNvPr id="12" name="">
             <a:extLst xmlns:a="http://schemas.openxmlformats.org/drawingml/2006/main">
               <a:ext uri="{FF2B5EF4-FFF2-40B4-BE49-F238E27FC236}">
-                <a16:creationId xmlns:a16="http://schemas.microsoft.com/office/drawing/2014/main" id="{2E886442-4874-4CE4-A916-E57810A93177}"/>
+                <a16:creationId xmlns:a16="http://schemas.microsoft.com/office/drawing/2014/main" id="{3AB532C1-3759-401A-B0CF-1D70E823116E}"/>
               </a:ext>
             </a:extLst>
           </p:cNvPr>
@@ -6151,7 +6151,7 @@
           <p:cNvPr id="13" name="">
             <a:extLst xmlns:a="http://schemas.openxmlformats.org/drawingml/2006/main">
               <a:ext uri="{FF2B5EF4-FFF2-40B4-BE49-F238E27FC236}">
-                <a16:creationId xmlns:a16="http://schemas.microsoft.com/office/drawing/2014/main" id="{82BEFC4F-CC26-4CA9-B6B9-7837E9D766CF}"/>
+                <a16:creationId xmlns:a16="http://schemas.microsoft.com/office/drawing/2014/main" id="{41DF9DB2-A786-4BE2-9BB4-F6C23E1E087F}"/>
               </a:ext>
             </a:extLst>
           </p:cNvPr>
@@ -6215,7 +6215,7 @@
           <p:cNvPr id="14" name="">
             <a:extLst xmlns:a="http://schemas.openxmlformats.org/drawingml/2006/main">
               <a:ext uri="{FF2B5EF4-FFF2-40B4-BE49-F238E27FC236}">
-                <a16:creationId xmlns:a16="http://schemas.microsoft.com/office/drawing/2014/main" id="{38905EEF-96B5-4D75-9B27-150E1D10809D}"/>
+                <a16:creationId xmlns:a16="http://schemas.microsoft.com/office/drawing/2014/main" id="{BBB8B7B9-FCCA-4B8C-B6A7-B31C2A6CF45B}"/>
               </a:ext>
             </a:extLst>
           </p:cNvPr>
@@ -6279,7 +6279,7 @@
           <p:cNvPr id="15" name="">
             <a:extLst xmlns:a="http://schemas.openxmlformats.org/drawingml/2006/main">
               <a:ext uri="{FF2B5EF4-FFF2-40B4-BE49-F238E27FC236}">
-                <a16:creationId xmlns:a16="http://schemas.microsoft.com/office/drawing/2014/main" id="{28C64288-7237-46A0-8250-2A12B591CE61}"/>
+                <a16:creationId xmlns:a16="http://schemas.microsoft.com/office/drawing/2014/main" id="{F7BD1BBA-39B1-4BBA-9E17-C5565C26B0E3}"/>
               </a:ext>
             </a:extLst>
           </p:cNvPr>
@@ -6314,7 +6314,7 @@
           <p:cNvPr id="16" name="">
             <a:extLst xmlns:a="http://schemas.openxmlformats.org/drawingml/2006/main">
               <a:ext uri="{FF2B5EF4-FFF2-40B4-BE49-F238E27FC236}">
-                <a16:creationId xmlns:a16="http://schemas.microsoft.com/office/drawing/2014/main" id="{5752AD3A-43E1-4D06-A450-ACEB80D5E613}"/>
+                <a16:creationId xmlns:a16="http://schemas.microsoft.com/office/drawing/2014/main" id="{A7BC44E0-4A4C-4C68-A56C-0FFBA4053E8D}"/>
               </a:ext>
             </a:extLst>
           </p:cNvPr>
@@ -6349,7 +6349,7 @@
           <p:cNvPr id="17" name="">
             <a:extLst xmlns:a="http://schemas.openxmlformats.org/drawingml/2006/main">
               <a:ext uri="{FF2B5EF4-FFF2-40B4-BE49-F238E27FC236}">
-                <a16:creationId xmlns:a16="http://schemas.microsoft.com/office/drawing/2014/main" id="{9DE3ACA5-92DB-4C6A-BF90-8B8298DCBAB9}"/>
+                <a16:creationId xmlns:a16="http://schemas.microsoft.com/office/drawing/2014/main" id="{845749FF-8D0C-4FA1-98B8-ED9199D8FD3B}"/>
               </a:ext>
             </a:extLst>
           </p:cNvPr>
@@ -6386,7 +6386,7 @@
           <p:nvPr/>
         </p:nvPicPr>
         <p:blipFill>
-          <a:blip xmlns:r="http://schemas.openxmlformats.org/officeDocument/2006/relationships" xmlns:a="http://schemas.openxmlformats.org/drawingml/2006/main" r:embed="R72d6abcb9aaa4131"/>
+          <a:blip xmlns:r="http://schemas.openxmlformats.org/officeDocument/2006/relationships" xmlns:a="http://schemas.openxmlformats.org/drawingml/2006/main" r:embed="Ra5d5b73296f647fb"/>
           <a:stretch xmlns:a="http://schemas.openxmlformats.org/drawingml/2006/main"/>
         </p:blipFill>
         <p:spPr>
@@ -6404,7 +6404,7 @@
           <p:cNvPr id="19" name="">
             <a:extLst xmlns:a="http://schemas.openxmlformats.org/drawingml/2006/main">
               <a:ext uri="{FF2B5EF4-FFF2-40B4-BE49-F238E27FC236}">
-                <a16:creationId xmlns:a16="http://schemas.microsoft.com/office/drawing/2014/main" id="{7A06677A-FA2B-446E-A1B1-85159BBAB58D}"/>
+                <a16:creationId xmlns:a16="http://schemas.microsoft.com/office/drawing/2014/main" id="{011C2928-277F-4A31-98E6-9791ADEECB34}"/>
               </a:ext>
             </a:extLst>
           </p:cNvPr>
@@ -6439,7 +6439,7 @@
           <p:cNvPr id="20" name="">
             <a:extLst xmlns:a="http://schemas.openxmlformats.org/drawingml/2006/main">
               <a:ext uri="{FF2B5EF4-FFF2-40B4-BE49-F238E27FC236}">
-                <a16:creationId xmlns:a16="http://schemas.microsoft.com/office/drawing/2014/main" id="{3E3DD525-5FFE-4857-B8A0-0E0B6800772D}"/>
+                <a16:creationId xmlns:a16="http://schemas.microsoft.com/office/drawing/2014/main" id="{3891D165-8884-4FC5-B4B7-E906BB6B6C41}"/>
               </a:ext>
             </a:extLst>
           </p:cNvPr>
@@ -6503,7 +6503,7 @@
           <p:cNvPr id="21" name="">
             <a:extLst xmlns:a="http://schemas.openxmlformats.org/drawingml/2006/main">
               <a:ext uri="{FF2B5EF4-FFF2-40B4-BE49-F238E27FC236}">
-                <a16:creationId xmlns:a16="http://schemas.microsoft.com/office/drawing/2014/main" id="{1E94E40D-5081-4BA0-A523-40B6BF0C17E4}"/>
+                <a16:creationId xmlns:a16="http://schemas.microsoft.com/office/drawing/2014/main" id="{C74DAC22-E336-4EFB-A89E-36F6168BB4A4}"/>
               </a:ext>
             </a:extLst>
           </p:cNvPr>
@@ -6536,7 +6536,7 @@
           <p:cNvPr id="22" name="">
             <a:extLst xmlns:a="http://schemas.openxmlformats.org/drawingml/2006/main">
               <a:ext uri="{FF2B5EF4-FFF2-40B4-BE49-F238E27FC236}">
-                <a16:creationId xmlns:a16="http://schemas.microsoft.com/office/drawing/2014/main" id="{8BE594E0-22CB-44A2-8098-87F9BCE8D274}"/>
+                <a16:creationId xmlns:a16="http://schemas.microsoft.com/office/drawing/2014/main" id="{32345C19-F9FF-4CB4-A850-696287F726AA}"/>
               </a:ext>
             </a:extLst>
           </p:cNvPr>
@@ -6600,7 +6600,7 @@
           <p:cNvPr id="23" name="">
             <a:extLst xmlns:a="http://schemas.openxmlformats.org/drawingml/2006/main">
               <a:ext uri="{FF2B5EF4-FFF2-40B4-BE49-F238E27FC236}">
-                <a16:creationId xmlns:a16="http://schemas.microsoft.com/office/drawing/2014/main" id="{F6D57825-C341-4F53-A2DA-FA0F502541E0}"/>
+                <a16:creationId xmlns:a16="http://schemas.microsoft.com/office/drawing/2014/main" id="{794E1F85-18AB-44D0-BBC4-810EAAB4AE8E}"/>
               </a:ext>
             </a:extLst>
           </p:cNvPr>
@@ -6664,7 +6664,7 @@
           <p:cNvPr id="24" name="">
             <a:extLst xmlns:a="http://schemas.openxmlformats.org/drawingml/2006/main">
               <a:ext uri="{FF2B5EF4-FFF2-40B4-BE49-F238E27FC236}">
-                <a16:creationId xmlns:a16="http://schemas.microsoft.com/office/drawing/2014/main" id="{19BAF131-5979-4CF5-B444-295BD891AB06}"/>
+                <a16:creationId xmlns:a16="http://schemas.microsoft.com/office/drawing/2014/main" id="{BC4F2F6E-C293-4E1E-8762-FB0414A307AA}"/>
               </a:ext>
             </a:extLst>
           </p:cNvPr>
@@ -6726,7 +6726,7 @@
     </p:spTree>
     <p:extLst>
       <p:ext uri="{BB962C8B-B14F-4D97-AF65-F5344CB8AC3E}">
-        <p14:creationId xmlns:p14="http://schemas.microsoft.com/office/powerpoint/2010/main" val="340388723"/>
+        <p14:creationId xmlns:p14="http://schemas.microsoft.com/office/powerpoint/2010/main" val="1674850255"/>
       </p:ext>
     </p:extLst>
   </p:cSld>
@@ -6750,7 +6750,7 @@
           <p:cNvPr id="1" name="">
             <a:extLst xmlns:a="http://schemas.openxmlformats.org/drawingml/2006/main">
               <a:ext uri="{FF2B5EF4-FFF2-40B4-BE49-F238E27FC236}">
-                <a16:creationId xmlns:a16="http://schemas.microsoft.com/office/drawing/2014/main" id="{906D30E4-2D7A-4FC6-B8C6-1E04F4A12A4F}"/>
+                <a16:creationId xmlns:a16="http://schemas.microsoft.com/office/drawing/2014/main" id="{53B6DF55-E24B-4905-AD63-FD4478EEB27A}"/>
               </a:ext>
             </a:extLst>
           </p:cNvPr>
@@ -6785,7 +6785,7 @@
           <p:cNvPr id="2" name="">
             <a:extLst xmlns:a="http://schemas.openxmlformats.org/drawingml/2006/main">
               <a:ext uri="{FF2B5EF4-FFF2-40B4-BE49-F238E27FC236}">
-                <a16:creationId xmlns:a16="http://schemas.microsoft.com/office/drawing/2014/main" id="{B8506379-7297-4F08-990B-6E408B7296FC}"/>
+                <a16:creationId xmlns:a16="http://schemas.microsoft.com/office/drawing/2014/main" id="{686ACF6B-2B7B-4451-847B-E21038C7D42C}"/>
               </a:ext>
             </a:extLst>
           </p:cNvPr>
@@ -6820,7 +6820,7 @@
           <p:cNvPr id="3" name="">
             <a:extLst xmlns:a="http://schemas.openxmlformats.org/drawingml/2006/main">
               <a:ext uri="{FF2B5EF4-FFF2-40B4-BE49-F238E27FC236}">
-                <a16:creationId xmlns:a16="http://schemas.microsoft.com/office/drawing/2014/main" id="{37F3244A-C15A-45C9-96F7-1745757F1ACB}"/>
+                <a16:creationId xmlns:a16="http://schemas.microsoft.com/office/drawing/2014/main" id="{6E103C0F-25E5-4F70-8C54-53B822BE8B66}"/>
               </a:ext>
             </a:extLst>
           </p:cNvPr>
@@ -6884,7 +6884,7 @@
           <p:cNvPr id="4" name="">
             <a:extLst xmlns:a="http://schemas.openxmlformats.org/drawingml/2006/main">
               <a:ext uri="{FF2B5EF4-FFF2-40B4-BE49-F238E27FC236}">
-                <a16:creationId xmlns:a16="http://schemas.microsoft.com/office/drawing/2014/main" id="{3B2359A9-A270-44C0-BCFA-79F16F12D857}"/>
+                <a16:creationId xmlns:a16="http://schemas.microsoft.com/office/drawing/2014/main" id="{8040E971-2C80-48F1-AE95-A48980DBF262}"/>
               </a:ext>
             </a:extLst>
           </p:cNvPr>
@@ -6948,7 +6948,7 @@
           <p:cNvPr id="5" name="">
             <a:extLst xmlns:a="http://schemas.openxmlformats.org/drawingml/2006/main">
               <a:ext uri="{FF2B5EF4-FFF2-40B4-BE49-F238E27FC236}">
-                <a16:creationId xmlns:a16="http://schemas.microsoft.com/office/drawing/2014/main" id="{36823D10-33E8-4739-9680-5D2311B31C19}"/>
+                <a16:creationId xmlns:a16="http://schemas.microsoft.com/office/drawing/2014/main" id="{7BED0232-2E95-4D3C-A9F1-7611E2B73094}"/>
               </a:ext>
             </a:extLst>
           </p:cNvPr>
@@ -7012,7 +7012,7 @@
           <p:cNvPr id="6" name="">
             <a:extLst xmlns:a="http://schemas.openxmlformats.org/drawingml/2006/main">
               <a:ext uri="{FF2B5EF4-FFF2-40B4-BE49-F238E27FC236}">
-                <a16:creationId xmlns:a16="http://schemas.microsoft.com/office/drawing/2014/main" id="{712B2A97-BD87-4177-94A5-4D46EA38D5FD}"/>
+                <a16:creationId xmlns:a16="http://schemas.microsoft.com/office/drawing/2014/main" id="{C31B5B01-855C-43F2-822F-6095AA88EF91}"/>
               </a:ext>
             </a:extLst>
           </p:cNvPr>
@@ -7045,7 +7045,7 @@
           <p:cNvPr id="7" name="">
             <a:extLst xmlns:a="http://schemas.openxmlformats.org/drawingml/2006/main">
               <a:ext uri="{FF2B5EF4-FFF2-40B4-BE49-F238E27FC236}">
-                <a16:creationId xmlns:a16="http://schemas.microsoft.com/office/drawing/2014/main" id="{EA07B133-DBA5-4EE5-99F2-37737A31BDF8}"/>
+                <a16:creationId xmlns:a16="http://schemas.microsoft.com/office/drawing/2014/main" id="{59D951AB-9138-49EE-AC8F-698EFFFC97DE}"/>
               </a:ext>
             </a:extLst>
           </p:cNvPr>
@@ -7078,7 +7078,7 @@
           <p:cNvPr id="8" name="">
             <a:extLst xmlns:a="http://schemas.openxmlformats.org/drawingml/2006/main">
               <a:ext uri="{FF2B5EF4-FFF2-40B4-BE49-F238E27FC236}">
-                <a16:creationId xmlns:a16="http://schemas.microsoft.com/office/drawing/2014/main" id="{9CB0F422-58F4-4F3A-8095-0424ADBE60DE}"/>
+                <a16:creationId xmlns:a16="http://schemas.microsoft.com/office/drawing/2014/main" id="{9B0FDD43-4CED-4B84-A337-F33F95AC6CED}"/>
               </a:ext>
             </a:extLst>
           </p:cNvPr>
@@ -7142,7 +7142,7 @@
           <p:cNvPr id="9" name="">
             <a:extLst xmlns:a="http://schemas.openxmlformats.org/drawingml/2006/main">
               <a:ext uri="{FF2B5EF4-FFF2-40B4-BE49-F238E27FC236}">
-                <a16:creationId xmlns:a16="http://schemas.microsoft.com/office/drawing/2014/main" id="{0D6BCD26-A159-4541-9A35-4ADD79C4FA78}"/>
+                <a16:creationId xmlns:a16="http://schemas.microsoft.com/office/drawing/2014/main" id="{10ADD122-F8DB-49CE-AFB7-1EED10A125C3}"/>
               </a:ext>
             </a:extLst>
           </p:cNvPr>
@@ -7206,7 +7206,7 @@
           <p:cNvPr id="10" name="">
             <a:extLst xmlns:a="http://schemas.openxmlformats.org/drawingml/2006/main">
               <a:ext uri="{FF2B5EF4-FFF2-40B4-BE49-F238E27FC236}">
-                <a16:creationId xmlns:a16="http://schemas.microsoft.com/office/drawing/2014/main" id="{6886AF29-E657-47F5-A0DB-633EA485B476}"/>
+                <a16:creationId xmlns:a16="http://schemas.microsoft.com/office/drawing/2014/main" id="{5D839DC2-2408-4AE1-81C0-F6A1C2BDD94A}"/>
               </a:ext>
             </a:extLst>
           </p:cNvPr>
@@ -7239,7 +7239,7 @@
           <p:cNvPr id="11" name="">
             <a:extLst xmlns:a="http://schemas.openxmlformats.org/drawingml/2006/main">
               <a:ext uri="{FF2B5EF4-FFF2-40B4-BE49-F238E27FC236}">
-                <a16:creationId xmlns:a16="http://schemas.microsoft.com/office/drawing/2014/main" id="{9DD876EA-CD6C-478B-8423-171D0EB1E78C}"/>
+                <a16:creationId xmlns:a16="http://schemas.microsoft.com/office/drawing/2014/main" id="{222EED30-F037-4D6F-82FC-8F10A52BD08C}"/>
               </a:ext>
             </a:extLst>
           </p:cNvPr>
@@ -7303,7 +7303,7 @@
           <p:cNvPr id="12" name="">
             <a:extLst xmlns:a="http://schemas.openxmlformats.org/drawingml/2006/main">
               <a:ext uri="{FF2B5EF4-FFF2-40B4-BE49-F238E27FC236}">
-                <a16:creationId xmlns:a16="http://schemas.microsoft.com/office/drawing/2014/main" id="{A8D533DB-FE61-423E-80C1-4612F8D30F6F}"/>
+                <a16:creationId xmlns:a16="http://schemas.microsoft.com/office/drawing/2014/main" id="{FEF1E349-DFED-4B8E-86DA-165283C1B1F8}"/>
               </a:ext>
             </a:extLst>
           </p:cNvPr>
@@ -7357,7 +7357,7 @@
                 <a:ea typeface="Aptos"/>
                 <a:cs typeface="Aptos"/>
               </a:rPr>
-              <a:t>Meridian policy + tools</a:t>
+              <a:t>policy + tool gates</a:t>
             </a:r>
           </a:p>
         </p:txBody>
@@ -7367,7 +7367,7 @@
           <p:cNvPr id="13" name="">
             <a:extLst xmlns:a="http://schemas.openxmlformats.org/drawingml/2006/main">
               <a:ext uri="{FF2B5EF4-FFF2-40B4-BE49-F238E27FC236}">
-                <a16:creationId xmlns:a16="http://schemas.microsoft.com/office/drawing/2014/main" id="{273C73C0-2E7F-448D-9034-823AE42C8BE9}"/>
+                <a16:creationId xmlns:a16="http://schemas.microsoft.com/office/drawing/2014/main" id="{1C2B8536-670E-44F4-ACEC-CFB2B31BFAD9}"/>
               </a:ext>
             </a:extLst>
           </p:cNvPr>
@@ -7400,7 +7400,7 @@
           <p:cNvPr id="14" name="">
             <a:extLst xmlns:a="http://schemas.openxmlformats.org/drawingml/2006/main">
               <a:ext uri="{FF2B5EF4-FFF2-40B4-BE49-F238E27FC236}">
-                <a16:creationId xmlns:a16="http://schemas.microsoft.com/office/drawing/2014/main" id="{195B5755-1519-40F3-939A-E021469E8014}"/>
+                <a16:creationId xmlns:a16="http://schemas.microsoft.com/office/drawing/2014/main" id="{DCE1F840-6719-48B5-9092-26CF458BA40A}"/>
               </a:ext>
             </a:extLst>
           </p:cNvPr>
@@ -7464,7 +7464,7 @@
           <p:cNvPr id="15" name="">
             <a:extLst xmlns:a="http://schemas.openxmlformats.org/drawingml/2006/main">
               <a:ext uri="{FF2B5EF4-FFF2-40B4-BE49-F238E27FC236}">
-                <a16:creationId xmlns:a16="http://schemas.microsoft.com/office/drawing/2014/main" id="{9A49F6DD-5087-4E71-AA39-32AF3D56BE47}"/>
+                <a16:creationId xmlns:a16="http://schemas.microsoft.com/office/drawing/2014/main" id="{C6E5E458-7805-42D1-AB6F-3770CC2BA038}"/>
               </a:ext>
             </a:extLst>
           </p:cNvPr>
@@ -7528,7 +7528,7 @@
           <p:cNvPr id="16" name="">
             <a:extLst xmlns:a="http://schemas.openxmlformats.org/drawingml/2006/main">
               <a:ext uri="{FF2B5EF4-FFF2-40B4-BE49-F238E27FC236}">
-                <a16:creationId xmlns:a16="http://schemas.microsoft.com/office/drawing/2014/main" id="{1B15CF68-DE09-4F10-A875-063DEB1D685F}"/>
+                <a16:creationId xmlns:a16="http://schemas.microsoft.com/office/drawing/2014/main" id="{0DE2FD90-1CF1-4A5F-A62F-50B8FD257E05}"/>
               </a:ext>
             </a:extLst>
           </p:cNvPr>
@@ -7561,7 +7561,7 @@
           <p:cNvPr id="17" name="">
             <a:extLst xmlns:a="http://schemas.openxmlformats.org/drawingml/2006/main">
               <a:ext uri="{FF2B5EF4-FFF2-40B4-BE49-F238E27FC236}">
-                <a16:creationId xmlns:a16="http://schemas.microsoft.com/office/drawing/2014/main" id="{D7973251-30D3-41AC-8479-66F4A8070AAD}"/>
+                <a16:creationId xmlns:a16="http://schemas.microsoft.com/office/drawing/2014/main" id="{3DA60A78-B1C2-4818-AD04-3D5CE9AE5A5B}"/>
               </a:ext>
             </a:extLst>
           </p:cNvPr>
@@ -7625,7 +7625,7 @@
           <p:cNvPr id="18" name="">
             <a:extLst xmlns:a="http://schemas.openxmlformats.org/drawingml/2006/main">
               <a:ext uri="{FF2B5EF4-FFF2-40B4-BE49-F238E27FC236}">
-                <a16:creationId xmlns:a16="http://schemas.microsoft.com/office/drawing/2014/main" id="{E41BE5C5-74E0-4D5C-9DF9-E261D159F51F}"/>
+                <a16:creationId xmlns:a16="http://schemas.microsoft.com/office/drawing/2014/main" id="{12549FDE-BD41-4CE8-9BAA-0A061B02D744}"/>
               </a:ext>
             </a:extLst>
           </p:cNvPr>
@@ -7689,7 +7689,7 @@
           <p:cNvPr id="19" name="">
             <a:extLst xmlns:a="http://schemas.openxmlformats.org/drawingml/2006/main">
               <a:ext uri="{FF2B5EF4-FFF2-40B4-BE49-F238E27FC236}">
-                <a16:creationId xmlns:a16="http://schemas.microsoft.com/office/drawing/2014/main" id="{F63A72A2-049B-4071-809A-92542EF53C29}"/>
+                <a16:creationId xmlns:a16="http://schemas.microsoft.com/office/drawing/2014/main" id="{6510EBB8-6DDB-4461-BAC1-A70AEBD0278E}"/>
               </a:ext>
             </a:extLst>
           </p:cNvPr>
@@ -7722,7 +7722,7 @@
           <p:cNvPr id="20" name="">
             <a:extLst xmlns:a="http://schemas.openxmlformats.org/drawingml/2006/main">
               <a:ext uri="{FF2B5EF4-FFF2-40B4-BE49-F238E27FC236}">
-                <a16:creationId xmlns:a16="http://schemas.microsoft.com/office/drawing/2014/main" id="{66D44F2A-D760-4905-81A9-124CC7579DE4}"/>
+                <a16:creationId xmlns:a16="http://schemas.microsoft.com/office/drawing/2014/main" id="{7EEC3A1B-C59B-4F7F-9D2C-6C0F1E908194}"/>
               </a:ext>
             </a:extLst>
           </p:cNvPr>
@@ -7786,7 +7786,7 @@
           <p:cNvPr id="21" name="">
             <a:extLst xmlns:a="http://schemas.openxmlformats.org/drawingml/2006/main">
               <a:ext uri="{FF2B5EF4-FFF2-40B4-BE49-F238E27FC236}">
-                <a16:creationId xmlns:a16="http://schemas.microsoft.com/office/drawing/2014/main" id="{ACE03154-D888-47E0-BC40-0F12282FBEBA}"/>
+                <a16:creationId xmlns:a16="http://schemas.microsoft.com/office/drawing/2014/main" id="{A010AEA6-C8EF-43A1-9EB8-501221AEEF03}"/>
               </a:ext>
             </a:extLst>
           </p:cNvPr>
@@ -7850,7 +7850,7 @@
           <p:cNvPr id="22" name="">
             <a:extLst xmlns:a="http://schemas.openxmlformats.org/drawingml/2006/main">
               <a:ext uri="{FF2B5EF4-FFF2-40B4-BE49-F238E27FC236}">
-                <a16:creationId xmlns:a16="http://schemas.microsoft.com/office/drawing/2014/main" id="{3864A8C5-0E87-4595-B5E8-210136B3EE98}"/>
+                <a16:creationId xmlns:a16="http://schemas.microsoft.com/office/drawing/2014/main" id="{9FE2D29A-70E7-42B4-9DE5-031B2908E659}"/>
               </a:ext>
             </a:extLst>
           </p:cNvPr>
@@ -7885,7 +7885,7 @@
           <p:cNvPr id="23" name="">
             <a:extLst xmlns:a="http://schemas.openxmlformats.org/drawingml/2006/main">
               <a:ext uri="{FF2B5EF4-FFF2-40B4-BE49-F238E27FC236}">
-                <a16:creationId xmlns:a16="http://schemas.microsoft.com/office/drawing/2014/main" id="{FC25DDCB-CD6F-4DD1-ACC4-AE681691BAC4}"/>
+                <a16:creationId xmlns:a16="http://schemas.microsoft.com/office/drawing/2014/main" id="{02C35D3C-4587-4513-B8C9-97169349A3A2}"/>
               </a:ext>
             </a:extLst>
           </p:cNvPr>
@@ -7920,7 +7920,7 @@
           <p:cNvPr id="24" name="">
             <a:extLst xmlns:a="http://schemas.openxmlformats.org/drawingml/2006/main">
               <a:ext uri="{FF2B5EF4-FFF2-40B4-BE49-F238E27FC236}">
-                <a16:creationId xmlns:a16="http://schemas.microsoft.com/office/drawing/2014/main" id="{0D3EAA40-9979-4B71-B770-DB8534AD8737}"/>
+                <a16:creationId xmlns:a16="http://schemas.microsoft.com/office/drawing/2014/main" id="{28EDCD33-9C80-438C-BEF3-920E248DCAD7}"/>
               </a:ext>
             </a:extLst>
           </p:cNvPr>
@@ -7955,7 +7955,7 @@
           <p:cNvPr id="25" name="">
             <a:extLst xmlns:a="http://schemas.openxmlformats.org/drawingml/2006/main">
               <a:ext uri="{FF2B5EF4-FFF2-40B4-BE49-F238E27FC236}">
-                <a16:creationId xmlns:a16="http://schemas.microsoft.com/office/drawing/2014/main" id="{A3887CFF-0B8E-4535-8E9F-70810DFAE01B}"/>
+                <a16:creationId xmlns:a16="http://schemas.microsoft.com/office/drawing/2014/main" id="{144FD5BC-3CD3-441C-A952-3025F62EB08B}"/>
               </a:ext>
             </a:extLst>
           </p:cNvPr>
@@ -7990,7 +7990,7 @@
           <p:cNvPr id="26" name="">
             <a:extLst xmlns:a="http://schemas.openxmlformats.org/drawingml/2006/main">
               <a:ext uri="{FF2B5EF4-FFF2-40B4-BE49-F238E27FC236}">
-                <a16:creationId xmlns:a16="http://schemas.microsoft.com/office/drawing/2014/main" id="{37EF221A-3594-41A6-B32D-E1045889BAAB}"/>
+                <a16:creationId xmlns:a16="http://schemas.microsoft.com/office/drawing/2014/main" id="{0D40CD63-86E2-4948-93FC-2797C9C4DE71}"/>
               </a:ext>
             </a:extLst>
           </p:cNvPr>
@@ -8025,7 +8025,7 @@
           <p:cNvPr id="27" name="">
             <a:extLst xmlns:a="http://schemas.openxmlformats.org/drawingml/2006/main">
               <a:ext uri="{FF2B5EF4-FFF2-40B4-BE49-F238E27FC236}">
-                <a16:creationId xmlns:a16="http://schemas.microsoft.com/office/drawing/2014/main" id="{16B7E2EB-A76B-47FC-A783-EC2D20E1ED93}"/>
+                <a16:creationId xmlns:a16="http://schemas.microsoft.com/office/drawing/2014/main" id="{6D569D6E-6040-4B5E-A8E3-2F68666A8F59}"/>
               </a:ext>
             </a:extLst>
           </p:cNvPr>
@@ -8060,7 +8060,7 @@
           <p:cNvPr id="28" name="">
             <a:extLst xmlns:a="http://schemas.openxmlformats.org/drawingml/2006/main">
               <a:ext uri="{FF2B5EF4-FFF2-40B4-BE49-F238E27FC236}">
-                <a16:creationId xmlns:a16="http://schemas.microsoft.com/office/drawing/2014/main" id="{52F1AF32-E812-460B-87DD-E8E681CB83CE}"/>
+                <a16:creationId xmlns:a16="http://schemas.microsoft.com/office/drawing/2014/main" id="{2A3F27C9-4C11-4107-BE8D-90E0D268C781}"/>
               </a:ext>
             </a:extLst>
           </p:cNvPr>
@@ -8095,7 +8095,7 @@
           <p:cNvPr id="29" name="">
             <a:extLst xmlns:a="http://schemas.openxmlformats.org/drawingml/2006/main">
               <a:ext uri="{FF2B5EF4-FFF2-40B4-BE49-F238E27FC236}">
-                <a16:creationId xmlns:a16="http://schemas.microsoft.com/office/drawing/2014/main" id="{3CCEC217-78C6-4977-A858-00C9D5A1DC7E}"/>
+                <a16:creationId xmlns:a16="http://schemas.microsoft.com/office/drawing/2014/main" id="{8C1311F1-1641-41E2-A9C7-996A7F1F4C4E}"/>
               </a:ext>
             </a:extLst>
           </p:cNvPr>
@@ -8130,7 +8130,7 @@
           <p:cNvPr id="30" name="">
             <a:extLst xmlns:a="http://schemas.openxmlformats.org/drawingml/2006/main">
               <a:ext uri="{FF2B5EF4-FFF2-40B4-BE49-F238E27FC236}">
-                <a16:creationId xmlns:a16="http://schemas.microsoft.com/office/drawing/2014/main" id="{0E8CD3B7-C993-4D65-8445-77954488656E}"/>
+                <a16:creationId xmlns:a16="http://schemas.microsoft.com/office/drawing/2014/main" id="{93904FEB-E2AD-4AE7-BF0F-69AD94AC3A83}"/>
               </a:ext>
             </a:extLst>
           </p:cNvPr>
@@ -8163,7 +8163,7 @@
           <p:cNvPr id="31" name="">
             <a:extLst xmlns:a="http://schemas.openxmlformats.org/drawingml/2006/main">
               <a:ext uri="{FF2B5EF4-FFF2-40B4-BE49-F238E27FC236}">
-                <a16:creationId xmlns:a16="http://schemas.microsoft.com/office/drawing/2014/main" id="{9F73E374-CCD5-4305-8BE3-14E3DCB2923F}"/>
+                <a16:creationId xmlns:a16="http://schemas.microsoft.com/office/drawing/2014/main" id="{5F846B4A-B189-479D-8EC2-C3DD85438F37}"/>
               </a:ext>
             </a:extLst>
           </p:cNvPr>
@@ -8227,7 +8227,7 @@
           <p:cNvPr id="32" name="">
             <a:extLst xmlns:a="http://schemas.openxmlformats.org/drawingml/2006/main">
               <a:ext uri="{FF2B5EF4-FFF2-40B4-BE49-F238E27FC236}">
-                <a16:creationId xmlns:a16="http://schemas.microsoft.com/office/drawing/2014/main" id="{5DB13518-3403-4E45-B112-69D2424EBD97}"/>
+                <a16:creationId xmlns:a16="http://schemas.microsoft.com/office/drawing/2014/main" id="{E3AEEE69-6537-4CC8-9B5B-4F8FA1025394}"/>
               </a:ext>
             </a:extLst>
           </p:cNvPr>
@@ -8291,7 +8291,7 @@
           <p:cNvPr id="33" name="">
             <a:extLst xmlns:a="http://schemas.openxmlformats.org/drawingml/2006/main">
               <a:ext uri="{FF2B5EF4-FFF2-40B4-BE49-F238E27FC236}">
-                <a16:creationId xmlns:a16="http://schemas.microsoft.com/office/drawing/2014/main" id="{7208AC67-A5D9-481D-86BD-ADA99702B017}"/>
+                <a16:creationId xmlns:a16="http://schemas.microsoft.com/office/drawing/2014/main" id="{264483E3-BA69-4A76-919C-99D39BCA21D8}"/>
               </a:ext>
             </a:extLst>
           </p:cNvPr>
@@ -8324,7 +8324,7 @@
           <p:cNvPr id="34" name="">
             <a:extLst xmlns:a="http://schemas.openxmlformats.org/drawingml/2006/main">
               <a:ext uri="{FF2B5EF4-FFF2-40B4-BE49-F238E27FC236}">
-                <a16:creationId xmlns:a16="http://schemas.microsoft.com/office/drawing/2014/main" id="{62F489FE-72BA-4FF4-9078-99080938DC36}"/>
+                <a16:creationId xmlns:a16="http://schemas.microsoft.com/office/drawing/2014/main" id="{D218F3DB-28D7-4417-B88A-AE9CA9A9A147}"/>
               </a:ext>
             </a:extLst>
           </p:cNvPr>
@@ -8388,7 +8388,7 @@
           <p:cNvPr id="35" name="">
             <a:extLst xmlns:a="http://schemas.openxmlformats.org/drawingml/2006/main">
               <a:ext uri="{FF2B5EF4-FFF2-40B4-BE49-F238E27FC236}">
-                <a16:creationId xmlns:a16="http://schemas.microsoft.com/office/drawing/2014/main" id="{E6DFF9F0-913E-401F-B8BF-9C18D706B3C0}"/>
+                <a16:creationId xmlns:a16="http://schemas.microsoft.com/office/drawing/2014/main" id="{29B83776-1A59-4ED1-84A7-75192207F67C}"/>
               </a:ext>
             </a:extLst>
           </p:cNvPr>
@@ -8452,7 +8452,7 @@
           <p:cNvPr id="36" name="">
             <a:extLst xmlns:a="http://schemas.openxmlformats.org/drawingml/2006/main">
               <a:ext uri="{FF2B5EF4-FFF2-40B4-BE49-F238E27FC236}">
-                <a16:creationId xmlns:a16="http://schemas.microsoft.com/office/drawing/2014/main" id="{9A154283-5C88-462D-BE80-C5C68E8DBCEF}"/>
+                <a16:creationId xmlns:a16="http://schemas.microsoft.com/office/drawing/2014/main" id="{B01E04BB-48C5-46E4-A14C-E9C1498B4753}"/>
               </a:ext>
             </a:extLst>
           </p:cNvPr>
@@ -8485,7 +8485,7 @@
           <p:cNvPr id="37" name="">
             <a:extLst xmlns:a="http://schemas.openxmlformats.org/drawingml/2006/main">
               <a:ext uri="{FF2B5EF4-FFF2-40B4-BE49-F238E27FC236}">
-                <a16:creationId xmlns:a16="http://schemas.microsoft.com/office/drawing/2014/main" id="{F09C6EF8-0252-4588-BD62-E4421D596193}"/>
+                <a16:creationId xmlns:a16="http://schemas.microsoft.com/office/drawing/2014/main" id="{A39B797A-05FB-4F9F-92A5-58945B0E5DC1}"/>
               </a:ext>
             </a:extLst>
           </p:cNvPr>
@@ -8549,7 +8549,7 @@
           <p:cNvPr id="38" name="">
             <a:extLst xmlns:a="http://schemas.openxmlformats.org/drawingml/2006/main">
               <a:ext uri="{FF2B5EF4-FFF2-40B4-BE49-F238E27FC236}">
-                <a16:creationId xmlns:a16="http://schemas.microsoft.com/office/drawing/2014/main" id="{8B497403-7345-4FA2-BF2A-9414B7DB9EC3}"/>
+                <a16:creationId xmlns:a16="http://schemas.microsoft.com/office/drawing/2014/main" id="{1923C8CA-2F78-4AF6-9CA6-9E72D095E602}"/>
               </a:ext>
             </a:extLst>
           </p:cNvPr>
@@ -8613,7 +8613,7 @@
           <p:cNvPr id="39" name="">
             <a:extLst xmlns:a="http://schemas.openxmlformats.org/drawingml/2006/main">
               <a:ext uri="{FF2B5EF4-FFF2-40B4-BE49-F238E27FC236}">
-                <a16:creationId xmlns:a16="http://schemas.microsoft.com/office/drawing/2014/main" id="{FB8232F2-8EAE-475E-8308-96F09F527314}"/>
+                <a16:creationId xmlns:a16="http://schemas.microsoft.com/office/drawing/2014/main" id="{BEC0801D-A89B-41DD-9A0E-D8D355CAC997}"/>
               </a:ext>
             </a:extLst>
           </p:cNvPr>
@@ -8648,7 +8648,7 @@
           <p:cNvPr id="40" name="">
             <a:extLst xmlns:a="http://schemas.openxmlformats.org/drawingml/2006/main">
               <a:ext uri="{FF2B5EF4-FFF2-40B4-BE49-F238E27FC236}">
-                <a16:creationId xmlns:a16="http://schemas.microsoft.com/office/drawing/2014/main" id="{6D8531E6-728F-43C3-9585-385D5E28A012}"/>
+                <a16:creationId xmlns:a16="http://schemas.microsoft.com/office/drawing/2014/main" id="{8F9353E6-3E4C-4647-BD29-DB0D221B5AAF}"/>
               </a:ext>
             </a:extLst>
           </p:cNvPr>
@@ -8683,7 +8683,7 @@
           <p:cNvPr id="41" name="">
             <a:extLst xmlns:a="http://schemas.openxmlformats.org/drawingml/2006/main">
               <a:ext uri="{FF2B5EF4-FFF2-40B4-BE49-F238E27FC236}">
-                <a16:creationId xmlns:a16="http://schemas.microsoft.com/office/drawing/2014/main" id="{B540ECA2-DCAD-4D53-8A1A-3EDF4EF676FB}"/>
+                <a16:creationId xmlns:a16="http://schemas.microsoft.com/office/drawing/2014/main" id="{014FA575-A410-44E6-978C-AE99064D376E}"/>
               </a:ext>
             </a:extLst>
           </p:cNvPr>
@@ -8718,7 +8718,7 @@
           <p:cNvPr id="42" name="">
             <a:extLst xmlns:a="http://schemas.openxmlformats.org/drawingml/2006/main">
               <a:ext uri="{FF2B5EF4-FFF2-40B4-BE49-F238E27FC236}">
-                <a16:creationId xmlns:a16="http://schemas.microsoft.com/office/drawing/2014/main" id="{78C23A72-A496-4A2D-BE47-C590BAFD7C70}"/>
+                <a16:creationId xmlns:a16="http://schemas.microsoft.com/office/drawing/2014/main" id="{AF96C890-FA38-4D81-8314-A8D083261096}"/>
               </a:ext>
             </a:extLst>
           </p:cNvPr>
@@ -8753,7 +8753,7 @@
           <p:cNvPr id="43" name="">
             <a:extLst xmlns:a="http://schemas.openxmlformats.org/drawingml/2006/main">
               <a:ext uri="{FF2B5EF4-FFF2-40B4-BE49-F238E27FC236}">
-                <a16:creationId xmlns:a16="http://schemas.microsoft.com/office/drawing/2014/main" id="{62470B70-37B1-4709-B3FB-EF2DE5BC8899}"/>
+                <a16:creationId xmlns:a16="http://schemas.microsoft.com/office/drawing/2014/main" id="{96CE53A1-98E0-4F78-B681-B78A20D3F076}"/>
               </a:ext>
             </a:extLst>
           </p:cNvPr>
@@ -8788,7 +8788,7 @@
           <p:cNvPr id="44" name="">
             <a:extLst xmlns:a="http://schemas.openxmlformats.org/drawingml/2006/main">
               <a:ext uri="{FF2B5EF4-FFF2-40B4-BE49-F238E27FC236}">
-                <a16:creationId xmlns:a16="http://schemas.microsoft.com/office/drawing/2014/main" id="{FF5F87F9-C8A5-4578-99FA-3B33F30220FE}"/>
+                <a16:creationId xmlns:a16="http://schemas.microsoft.com/office/drawing/2014/main" id="{CF8BCD58-E138-419C-9EAD-CD70DA8B3DC4}"/>
               </a:ext>
             </a:extLst>
           </p:cNvPr>
@@ -8823,7 +8823,7 @@
           <p:cNvPr id="45" name="">
             <a:extLst xmlns:a="http://schemas.openxmlformats.org/drawingml/2006/main">
               <a:ext uri="{FF2B5EF4-FFF2-40B4-BE49-F238E27FC236}">
-                <a16:creationId xmlns:a16="http://schemas.microsoft.com/office/drawing/2014/main" id="{EB0C8FF5-BD99-4AC5-95FB-6531228B2293}"/>
+                <a16:creationId xmlns:a16="http://schemas.microsoft.com/office/drawing/2014/main" id="{BACACAA0-D8E1-4221-9AB5-A8D0F227BFC1}"/>
               </a:ext>
             </a:extLst>
           </p:cNvPr>
@@ -8858,7 +8858,7 @@
           <p:cNvPr id="46" name="">
             <a:extLst xmlns:a="http://schemas.openxmlformats.org/drawingml/2006/main">
               <a:ext uri="{FF2B5EF4-FFF2-40B4-BE49-F238E27FC236}">
-                <a16:creationId xmlns:a16="http://schemas.microsoft.com/office/drawing/2014/main" id="{2E8A786E-D9FB-4279-9FD1-AD8EB2263995}"/>
+                <a16:creationId xmlns:a16="http://schemas.microsoft.com/office/drawing/2014/main" id="{5EC86608-1FBD-4D6A-B52D-F6C1CFC55751}"/>
               </a:ext>
             </a:extLst>
           </p:cNvPr>
@@ -8893,7 +8893,7 @@
           <p:cNvPr id="47" name="">
             <a:extLst xmlns:a="http://schemas.openxmlformats.org/drawingml/2006/main">
               <a:ext uri="{FF2B5EF4-FFF2-40B4-BE49-F238E27FC236}">
-                <a16:creationId xmlns:a16="http://schemas.microsoft.com/office/drawing/2014/main" id="{66B7E52C-9952-4BC2-8C0C-4EFB34E1A24A}"/>
+                <a16:creationId xmlns:a16="http://schemas.microsoft.com/office/drawing/2014/main" id="{925EB18D-0102-414A-976D-0AD36257FB5F}"/>
               </a:ext>
             </a:extLst>
           </p:cNvPr>
@@ -8957,7 +8957,7 @@
           <p:cNvPr id="48" name="">
             <a:extLst xmlns:a="http://schemas.openxmlformats.org/drawingml/2006/main">
               <a:ext uri="{FF2B5EF4-FFF2-40B4-BE49-F238E27FC236}">
-                <a16:creationId xmlns:a16="http://schemas.microsoft.com/office/drawing/2014/main" id="{A603C24F-23F9-45EA-A5F4-8D985DB6435E}"/>
+                <a16:creationId xmlns:a16="http://schemas.microsoft.com/office/drawing/2014/main" id="{53D42A4E-BBC6-4973-A0A2-633ED53C59B8}"/>
               </a:ext>
             </a:extLst>
           </p:cNvPr>
@@ -9067,7 +9067,7 @@
           <p:cNvPr id="49" name="">
             <a:extLst xmlns:a="http://schemas.openxmlformats.org/drawingml/2006/main">
               <a:ext uri="{FF2B5EF4-FFF2-40B4-BE49-F238E27FC236}">
-                <a16:creationId xmlns:a16="http://schemas.microsoft.com/office/drawing/2014/main" id="{725F46C4-A905-4FBA-9C9A-30483164D257}"/>
+                <a16:creationId xmlns:a16="http://schemas.microsoft.com/office/drawing/2014/main" id="{F5B237B2-A79D-48D6-A7E4-6D9CD4E9CBCE}"/>
               </a:ext>
             </a:extLst>
           </p:cNvPr>
@@ -9131,7 +9131,7 @@
           <p:cNvPr id="50" name="">
             <a:extLst xmlns:a="http://schemas.openxmlformats.org/drawingml/2006/main">
               <a:ext uri="{FF2B5EF4-FFF2-40B4-BE49-F238E27FC236}">
-                <a16:creationId xmlns:a16="http://schemas.microsoft.com/office/drawing/2014/main" id="{5BB2845A-11F9-4B1E-946C-E7B672BAEFE4}"/>
+                <a16:creationId xmlns:a16="http://schemas.microsoft.com/office/drawing/2014/main" id="{CD62BD10-C476-436D-B395-93A6A3C892E2}"/>
               </a:ext>
             </a:extLst>
           </p:cNvPr>
@@ -9193,7 +9193,7 @@
     </p:spTree>
     <p:extLst>
       <p:ext uri="{BB962C8B-B14F-4D97-AF65-F5344CB8AC3E}">
-        <p14:creationId xmlns:p14="http://schemas.microsoft.com/office/powerpoint/2010/main" val="1789746991"/>
+        <p14:creationId xmlns:p14="http://schemas.microsoft.com/office/powerpoint/2010/main" val="1093624192"/>
       </p:ext>
     </p:extLst>
   </p:cSld>
@@ -9217,7 +9217,7 @@
           <p:cNvPr id="1" name="">
             <a:extLst xmlns:a="http://schemas.openxmlformats.org/drawingml/2006/main">
               <a:ext uri="{FF2B5EF4-FFF2-40B4-BE49-F238E27FC236}">
-                <a16:creationId xmlns:a16="http://schemas.microsoft.com/office/drawing/2014/main" id="{2BEC1C8F-4096-4010-9A9C-A7E0B6A4E81B}"/>
+                <a16:creationId xmlns:a16="http://schemas.microsoft.com/office/drawing/2014/main" id="{79EA0DD0-56B0-4114-9812-ACB0F8CC5CBD}"/>
               </a:ext>
             </a:extLst>
           </p:cNvPr>
@@ -9252,7 +9252,7 @@
           <p:cNvPr id="2" name="">
             <a:extLst xmlns:a="http://schemas.openxmlformats.org/drawingml/2006/main">
               <a:ext uri="{FF2B5EF4-FFF2-40B4-BE49-F238E27FC236}">
-                <a16:creationId xmlns:a16="http://schemas.microsoft.com/office/drawing/2014/main" id="{E41AE4EE-4521-4D8E-BB47-36753DEBAD39}"/>
+                <a16:creationId xmlns:a16="http://schemas.microsoft.com/office/drawing/2014/main" id="{F668ABF5-671A-4F12-B9F3-DDE888FB2927}"/>
               </a:ext>
             </a:extLst>
           </p:cNvPr>
@@ -9287,7 +9287,7 @@
           <p:cNvPr id="3" name="">
             <a:extLst xmlns:a="http://schemas.openxmlformats.org/drawingml/2006/main">
               <a:ext uri="{FF2B5EF4-FFF2-40B4-BE49-F238E27FC236}">
-                <a16:creationId xmlns:a16="http://schemas.microsoft.com/office/drawing/2014/main" id="{9D2ADB5D-7029-4F98-8694-206D649DF1EB}"/>
+                <a16:creationId xmlns:a16="http://schemas.microsoft.com/office/drawing/2014/main" id="{6EA496DE-01DF-46BE-A744-E9F582439DC8}"/>
               </a:ext>
             </a:extLst>
           </p:cNvPr>
@@ -9351,7 +9351,7 @@
           <p:cNvPr id="4" name="">
             <a:extLst xmlns:a="http://schemas.openxmlformats.org/drawingml/2006/main">
               <a:ext uri="{FF2B5EF4-FFF2-40B4-BE49-F238E27FC236}">
-                <a16:creationId xmlns:a16="http://schemas.microsoft.com/office/drawing/2014/main" id="{791FCF19-E206-4F98-8071-CD488C74355C}"/>
+                <a16:creationId xmlns:a16="http://schemas.microsoft.com/office/drawing/2014/main" id="{8216C25A-1DEF-4ED5-B17A-7B2E6C6C3104}"/>
               </a:ext>
             </a:extLst>
           </p:cNvPr>
@@ -9415,7 +9415,7 @@
           <p:cNvPr id="5" name="">
             <a:extLst xmlns:a="http://schemas.openxmlformats.org/drawingml/2006/main">
               <a:ext uri="{FF2B5EF4-FFF2-40B4-BE49-F238E27FC236}">
-                <a16:creationId xmlns:a16="http://schemas.microsoft.com/office/drawing/2014/main" id="{2291D7A8-D6ED-4AC9-9DF3-EA25EBC9DB3E}"/>
+                <a16:creationId xmlns:a16="http://schemas.microsoft.com/office/drawing/2014/main" id="{F9F6F6D4-E60D-4503-AD7E-022535458DE8}"/>
               </a:ext>
             </a:extLst>
           </p:cNvPr>
@@ -9479,7 +9479,7 @@
           <p:cNvPr id="6" name="">
             <a:extLst xmlns:a="http://schemas.openxmlformats.org/drawingml/2006/main">
               <a:ext uri="{FF2B5EF4-FFF2-40B4-BE49-F238E27FC236}">
-                <a16:creationId xmlns:a16="http://schemas.microsoft.com/office/drawing/2014/main" id="{25A8311C-3310-4496-91F0-5981AE2EDE09}"/>
+                <a16:creationId xmlns:a16="http://schemas.microsoft.com/office/drawing/2014/main" id="{B540269D-1533-4BD6-895A-A74FB6454AD2}"/>
               </a:ext>
             </a:extLst>
           </p:cNvPr>
@@ -9512,7 +9512,7 @@
           <p:cNvPr id="7" name="">
             <a:extLst xmlns:a="http://schemas.openxmlformats.org/drawingml/2006/main">
               <a:ext uri="{FF2B5EF4-FFF2-40B4-BE49-F238E27FC236}">
-                <a16:creationId xmlns:a16="http://schemas.microsoft.com/office/drawing/2014/main" id="{33E0BC08-21BC-41D6-822F-79154A31C3CF}"/>
+                <a16:creationId xmlns:a16="http://schemas.microsoft.com/office/drawing/2014/main" id="{ABB98133-44F4-4941-ADE7-80B2C4AF9093}"/>
               </a:ext>
             </a:extLst>
           </p:cNvPr>
@@ -9576,7 +9576,7 @@
           <p:cNvPr id="8" name="">
             <a:extLst xmlns:a="http://schemas.openxmlformats.org/drawingml/2006/main">
               <a:ext uri="{FF2B5EF4-FFF2-40B4-BE49-F238E27FC236}">
-                <a16:creationId xmlns:a16="http://schemas.microsoft.com/office/drawing/2014/main" id="{9817EB0D-6CB6-424D-BCC7-38A79BEDF986}"/>
+                <a16:creationId xmlns:a16="http://schemas.microsoft.com/office/drawing/2014/main" id="{B31E7DD1-D0B0-4543-ACC4-A204E7089728}"/>
               </a:ext>
             </a:extLst>
           </p:cNvPr>
@@ -9640,7 +9640,7 @@
           <p:cNvPr id="9" name="">
             <a:extLst xmlns:a="http://schemas.openxmlformats.org/drawingml/2006/main">
               <a:ext uri="{FF2B5EF4-FFF2-40B4-BE49-F238E27FC236}">
-                <a16:creationId xmlns:a16="http://schemas.microsoft.com/office/drawing/2014/main" id="{D5BFE72C-D320-40CF-BC87-421A6785AA6B}"/>
+                <a16:creationId xmlns:a16="http://schemas.microsoft.com/office/drawing/2014/main" id="{9A607D17-FA06-4274-A941-278087644D4C}"/>
               </a:ext>
             </a:extLst>
           </p:cNvPr>
@@ -9704,7 +9704,7 @@
           <p:cNvPr id="10" name="">
             <a:extLst xmlns:a="http://schemas.openxmlformats.org/drawingml/2006/main">
               <a:ext uri="{FF2B5EF4-FFF2-40B4-BE49-F238E27FC236}">
-                <a16:creationId xmlns:a16="http://schemas.microsoft.com/office/drawing/2014/main" id="{42069336-5A4B-43FA-B781-D74A4AA85B0F}"/>
+                <a16:creationId xmlns:a16="http://schemas.microsoft.com/office/drawing/2014/main" id="{3663B027-27DC-4D4A-86D8-BEC719B41BE4}"/>
               </a:ext>
             </a:extLst>
           </p:cNvPr>
@@ -9768,7 +9768,7 @@
           <p:cNvPr id="11" name="">
             <a:extLst xmlns:a="http://schemas.openxmlformats.org/drawingml/2006/main">
               <a:ext uri="{FF2B5EF4-FFF2-40B4-BE49-F238E27FC236}">
-                <a16:creationId xmlns:a16="http://schemas.microsoft.com/office/drawing/2014/main" id="{036BEFCE-80A8-490D-8113-28B9A0150277}"/>
+                <a16:creationId xmlns:a16="http://schemas.microsoft.com/office/drawing/2014/main" id="{32983FC9-B59E-4867-926C-83536CEB80AC}"/>
               </a:ext>
             </a:extLst>
           </p:cNvPr>
@@ -9803,7 +9803,7 @@
           <p:cNvPr id="12" name="">
             <a:extLst xmlns:a="http://schemas.openxmlformats.org/drawingml/2006/main">
               <a:ext uri="{FF2B5EF4-FFF2-40B4-BE49-F238E27FC236}">
-                <a16:creationId xmlns:a16="http://schemas.microsoft.com/office/drawing/2014/main" id="{8F93690A-033F-4C19-AB6D-657BE54CD469}"/>
+                <a16:creationId xmlns:a16="http://schemas.microsoft.com/office/drawing/2014/main" id="{F8F08E39-6800-48BD-BA87-352B354D6EB0}"/>
               </a:ext>
             </a:extLst>
           </p:cNvPr>
@@ -9838,7 +9838,7 @@
           <p:cNvPr id="13" name="">
             <a:extLst xmlns:a="http://schemas.openxmlformats.org/drawingml/2006/main">
               <a:ext uri="{FF2B5EF4-FFF2-40B4-BE49-F238E27FC236}">
-                <a16:creationId xmlns:a16="http://schemas.microsoft.com/office/drawing/2014/main" id="{F00E7F34-F869-4050-8612-7601782351D1}"/>
+                <a16:creationId xmlns:a16="http://schemas.microsoft.com/office/drawing/2014/main" id="{245797B4-406F-427D-A1DD-98F5414970A6}"/>
               </a:ext>
             </a:extLst>
           </p:cNvPr>
@@ -9873,7 +9873,7 @@
           <p:cNvPr id="14" name="">
             <a:extLst xmlns:a="http://schemas.openxmlformats.org/drawingml/2006/main">
               <a:ext uri="{FF2B5EF4-FFF2-40B4-BE49-F238E27FC236}">
-                <a16:creationId xmlns:a16="http://schemas.microsoft.com/office/drawing/2014/main" id="{C55A2B03-9365-42D1-A553-D4761584C9F6}"/>
+                <a16:creationId xmlns:a16="http://schemas.microsoft.com/office/drawing/2014/main" id="{660B8C7F-9F54-4194-A27A-0E1161FD0EED}"/>
               </a:ext>
             </a:extLst>
           </p:cNvPr>
@@ -9937,7 +9937,7 @@
           <p:cNvPr id="15" name="">
             <a:extLst xmlns:a="http://schemas.openxmlformats.org/drawingml/2006/main">
               <a:ext uri="{FF2B5EF4-FFF2-40B4-BE49-F238E27FC236}">
-                <a16:creationId xmlns:a16="http://schemas.microsoft.com/office/drawing/2014/main" id="{E8BB2116-690E-4939-A31B-9D52E60E1E76}"/>
+                <a16:creationId xmlns:a16="http://schemas.microsoft.com/office/drawing/2014/main" id="{D7999737-212C-4140-9B6A-6CF7E87E0E76}"/>
               </a:ext>
             </a:extLst>
           </p:cNvPr>
@@ -10001,7 +10001,7 @@
           <p:cNvPr id="16" name="">
             <a:extLst xmlns:a="http://schemas.openxmlformats.org/drawingml/2006/main">
               <a:ext uri="{FF2B5EF4-FFF2-40B4-BE49-F238E27FC236}">
-                <a16:creationId xmlns:a16="http://schemas.microsoft.com/office/drawing/2014/main" id="{643B12AA-B091-4448-8F77-452DB56A1D94}"/>
+                <a16:creationId xmlns:a16="http://schemas.microsoft.com/office/drawing/2014/main" id="{51894ABC-767F-42E3-BD29-F53BE097826B}"/>
               </a:ext>
             </a:extLst>
           </p:cNvPr>
@@ -10036,7 +10036,7 @@
           <p:cNvPr id="17" name="">
             <a:extLst xmlns:a="http://schemas.openxmlformats.org/drawingml/2006/main">
               <a:ext uri="{FF2B5EF4-FFF2-40B4-BE49-F238E27FC236}">
-                <a16:creationId xmlns:a16="http://schemas.microsoft.com/office/drawing/2014/main" id="{75BD4958-849C-4796-B473-9EB5CCB37F73}"/>
+                <a16:creationId xmlns:a16="http://schemas.microsoft.com/office/drawing/2014/main" id="{ECB73D68-F3EE-4667-B06C-4A641886AA6A}"/>
               </a:ext>
             </a:extLst>
           </p:cNvPr>
@@ -10071,7 +10071,7 @@
           <p:cNvPr id="18" name="">
             <a:extLst xmlns:a="http://schemas.openxmlformats.org/drawingml/2006/main">
               <a:ext uri="{FF2B5EF4-FFF2-40B4-BE49-F238E27FC236}">
-                <a16:creationId xmlns:a16="http://schemas.microsoft.com/office/drawing/2014/main" id="{E1DB3294-BCFB-440F-AB85-F1730B5D01CE}"/>
+                <a16:creationId xmlns:a16="http://schemas.microsoft.com/office/drawing/2014/main" id="{CB6BBEC6-873F-4275-A733-E7CC818371E3}"/>
               </a:ext>
             </a:extLst>
           </p:cNvPr>
@@ -10106,7 +10106,7 @@
           <p:cNvPr id="19" name="">
             <a:extLst xmlns:a="http://schemas.openxmlformats.org/drawingml/2006/main">
               <a:ext uri="{FF2B5EF4-FFF2-40B4-BE49-F238E27FC236}">
-                <a16:creationId xmlns:a16="http://schemas.microsoft.com/office/drawing/2014/main" id="{F54B2957-4687-45E6-A633-203D354D7181}"/>
+                <a16:creationId xmlns:a16="http://schemas.microsoft.com/office/drawing/2014/main" id="{D7B86F4F-8525-4309-8867-092FDBB4C6F8}"/>
               </a:ext>
             </a:extLst>
           </p:cNvPr>
@@ -10170,7 +10170,7 @@
           <p:cNvPr id="20" name="">
             <a:extLst xmlns:a="http://schemas.openxmlformats.org/drawingml/2006/main">
               <a:ext uri="{FF2B5EF4-FFF2-40B4-BE49-F238E27FC236}">
-                <a16:creationId xmlns:a16="http://schemas.microsoft.com/office/drawing/2014/main" id="{928FDCC2-4390-452D-B156-E49792F0EA41}"/>
+                <a16:creationId xmlns:a16="http://schemas.microsoft.com/office/drawing/2014/main" id="{9EECB966-B8F9-4325-B933-A70CC293C18C}"/>
               </a:ext>
             </a:extLst>
           </p:cNvPr>
@@ -10234,7 +10234,7 @@
           <p:cNvPr id="21" name="">
             <a:extLst xmlns:a="http://schemas.openxmlformats.org/drawingml/2006/main">
               <a:ext uri="{FF2B5EF4-FFF2-40B4-BE49-F238E27FC236}">
-                <a16:creationId xmlns:a16="http://schemas.microsoft.com/office/drawing/2014/main" id="{14F3F408-E3D4-42E2-94C1-57684C463BE4}"/>
+                <a16:creationId xmlns:a16="http://schemas.microsoft.com/office/drawing/2014/main" id="{84423AB5-6476-4481-9C67-D7F545E98C89}"/>
               </a:ext>
             </a:extLst>
           </p:cNvPr>
@@ -10269,7 +10269,7 @@
           <p:cNvPr id="22" name="">
             <a:extLst xmlns:a="http://schemas.openxmlformats.org/drawingml/2006/main">
               <a:ext uri="{FF2B5EF4-FFF2-40B4-BE49-F238E27FC236}">
-                <a16:creationId xmlns:a16="http://schemas.microsoft.com/office/drawing/2014/main" id="{E28E2A76-E23B-452C-85C4-25349C7EB8EC}"/>
+                <a16:creationId xmlns:a16="http://schemas.microsoft.com/office/drawing/2014/main" id="{358B768B-22A1-4EE1-B208-17EF52E23201}"/>
               </a:ext>
             </a:extLst>
           </p:cNvPr>
@@ -10304,7 +10304,7 @@
           <p:cNvPr id="23" name="">
             <a:extLst xmlns:a="http://schemas.openxmlformats.org/drawingml/2006/main">
               <a:ext uri="{FF2B5EF4-FFF2-40B4-BE49-F238E27FC236}">
-                <a16:creationId xmlns:a16="http://schemas.microsoft.com/office/drawing/2014/main" id="{797618D1-9F93-49BD-93BF-B56FFB97074D}"/>
+                <a16:creationId xmlns:a16="http://schemas.microsoft.com/office/drawing/2014/main" id="{C4AB9221-7161-4B02-AFFD-C74A32A6A242}"/>
               </a:ext>
             </a:extLst>
           </p:cNvPr>
@@ -10339,7 +10339,7 @@
           <p:cNvPr id="24" name="">
             <a:extLst xmlns:a="http://schemas.openxmlformats.org/drawingml/2006/main">
               <a:ext uri="{FF2B5EF4-FFF2-40B4-BE49-F238E27FC236}">
-                <a16:creationId xmlns:a16="http://schemas.microsoft.com/office/drawing/2014/main" id="{21BBA865-7097-47E4-9187-ADF9FB0DCFA4}"/>
+                <a16:creationId xmlns:a16="http://schemas.microsoft.com/office/drawing/2014/main" id="{34814B32-7A0B-4C1A-A049-F49978A2BAB4}"/>
               </a:ext>
             </a:extLst>
           </p:cNvPr>
@@ -10403,7 +10403,7 @@
           <p:cNvPr id="25" name="">
             <a:extLst xmlns:a="http://schemas.openxmlformats.org/drawingml/2006/main">
               <a:ext uri="{FF2B5EF4-FFF2-40B4-BE49-F238E27FC236}">
-                <a16:creationId xmlns:a16="http://schemas.microsoft.com/office/drawing/2014/main" id="{CBB5BB2E-BC6B-4B08-96CF-922D0ADA7C86}"/>
+                <a16:creationId xmlns:a16="http://schemas.microsoft.com/office/drawing/2014/main" id="{82C0089F-E110-4ED7-B45C-1B770F033E72}"/>
               </a:ext>
             </a:extLst>
           </p:cNvPr>
@@ -10436,7 +10436,7 @@
           <p:cNvPr id="26" name="">
             <a:extLst xmlns:a="http://schemas.openxmlformats.org/drawingml/2006/main">
               <a:ext uri="{FF2B5EF4-FFF2-40B4-BE49-F238E27FC236}">
-                <a16:creationId xmlns:a16="http://schemas.microsoft.com/office/drawing/2014/main" id="{BBF3AF2D-B520-4943-B667-17C5561EC9C4}"/>
+                <a16:creationId xmlns:a16="http://schemas.microsoft.com/office/drawing/2014/main" id="{409D88BD-9D4E-4715-9D61-91EA1BCF4933}"/>
               </a:ext>
             </a:extLst>
           </p:cNvPr>
@@ -10500,7 +10500,7 @@
           <p:cNvPr id="27" name="">
             <a:extLst xmlns:a="http://schemas.openxmlformats.org/drawingml/2006/main">
               <a:ext uri="{FF2B5EF4-FFF2-40B4-BE49-F238E27FC236}">
-                <a16:creationId xmlns:a16="http://schemas.microsoft.com/office/drawing/2014/main" id="{5B803B82-F9BA-4AC5-B8A1-203355F180CD}"/>
+                <a16:creationId xmlns:a16="http://schemas.microsoft.com/office/drawing/2014/main" id="{3A664664-5430-4FD7-938D-041F7E7ACA3F}"/>
               </a:ext>
             </a:extLst>
           </p:cNvPr>
@@ -10533,7 +10533,7 @@
           <p:cNvPr id="28" name="">
             <a:extLst xmlns:a="http://schemas.openxmlformats.org/drawingml/2006/main">
               <a:ext uri="{FF2B5EF4-FFF2-40B4-BE49-F238E27FC236}">
-                <a16:creationId xmlns:a16="http://schemas.microsoft.com/office/drawing/2014/main" id="{AAEEEAEC-245D-4C41-8FD7-1F9156211C57}"/>
+                <a16:creationId xmlns:a16="http://schemas.microsoft.com/office/drawing/2014/main" id="{2A362DDB-CA99-48BB-91F6-E46471346610}"/>
               </a:ext>
             </a:extLst>
           </p:cNvPr>
@@ -10587,7 +10587,7 @@
                 <a:ea typeface="Aptos"/>
                 <a:cs typeface="Aptos"/>
               </a:rPr>
-              <a:t>Turn 1: normal balance</a:t>
+              <a:t>Turn 1: normal case status</a:t>
             </a:r>
           </a:p>
         </p:txBody>
@@ -10597,7 +10597,7 @@
           <p:cNvPr id="29" name="">
             <a:extLst xmlns:a="http://schemas.openxmlformats.org/drawingml/2006/main">
               <a:ext uri="{FF2B5EF4-FFF2-40B4-BE49-F238E27FC236}">
-                <a16:creationId xmlns:a16="http://schemas.microsoft.com/office/drawing/2014/main" id="{FA35F3A2-25A5-4299-874C-DF320C63DBC6}"/>
+                <a16:creationId xmlns:a16="http://schemas.microsoft.com/office/drawing/2014/main" id="{FBBEEDDF-D960-4914-A110-A33C8480189F}"/>
               </a:ext>
             </a:extLst>
           </p:cNvPr>
@@ -10661,7 +10661,7 @@
           <p:cNvPr id="30" name="">
             <a:extLst xmlns:a="http://schemas.openxmlformats.org/drawingml/2006/main">
               <a:ext uri="{FF2B5EF4-FFF2-40B4-BE49-F238E27FC236}">
-                <a16:creationId xmlns:a16="http://schemas.microsoft.com/office/drawing/2014/main" id="{A2127E45-4932-4699-A795-8A188BAF7DC9}"/>
+                <a16:creationId xmlns:a16="http://schemas.microsoft.com/office/drawing/2014/main" id="{70A5DA6A-0AC5-495D-92AB-331634A23E4F}"/>
               </a:ext>
             </a:extLst>
           </p:cNvPr>
@@ -10694,7 +10694,7 @@
           <p:cNvPr id="31" name="">
             <a:extLst xmlns:a="http://schemas.openxmlformats.org/drawingml/2006/main">
               <a:ext uri="{FF2B5EF4-FFF2-40B4-BE49-F238E27FC236}">
-                <a16:creationId xmlns:a16="http://schemas.microsoft.com/office/drawing/2014/main" id="{857C82A9-6A12-4A93-BE1E-FA1A9807D8E3}"/>
+                <a16:creationId xmlns:a16="http://schemas.microsoft.com/office/drawing/2014/main" id="{1393ED0C-D112-4F45-8513-7AFB951157E1}"/>
               </a:ext>
             </a:extLst>
           </p:cNvPr>
@@ -10758,7 +10758,7 @@
           <p:cNvPr id="32" name="">
             <a:extLst xmlns:a="http://schemas.openxmlformats.org/drawingml/2006/main">
               <a:ext uri="{FF2B5EF4-FFF2-40B4-BE49-F238E27FC236}">
-                <a16:creationId xmlns:a16="http://schemas.microsoft.com/office/drawing/2014/main" id="{1604A92B-5378-4AEC-BDC1-7670A556CE8E}"/>
+                <a16:creationId xmlns:a16="http://schemas.microsoft.com/office/drawing/2014/main" id="{0A795FE7-E94D-4BB0-9238-A15B72578CBF}"/>
               </a:ext>
             </a:extLst>
           </p:cNvPr>
@@ -10822,7 +10822,7 @@
           <p:cNvPr id="33" name="">
             <a:extLst xmlns:a="http://schemas.openxmlformats.org/drawingml/2006/main">
               <a:ext uri="{FF2B5EF4-FFF2-40B4-BE49-F238E27FC236}">
-                <a16:creationId xmlns:a16="http://schemas.microsoft.com/office/drawing/2014/main" id="{7772EC96-BB1E-4F30-A048-D9A1C64501D2}"/>
+                <a16:creationId xmlns:a16="http://schemas.microsoft.com/office/drawing/2014/main" id="{98E862AF-E19F-4EF9-AE5C-A8BA11633CB6}"/>
               </a:ext>
             </a:extLst>
           </p:cNvPr>
@@ -10855,7 +10855,7 @@
           <p:cNvPr id="34" name="">
             <a:extLst xmlns:a="http://schemas.openxmlformats.org/drawingml/2006/main">
               <a:ext uri="{FF2B5EF4-FFF2-40B4-BE49-F238E27FC236}">
-                <a16:creationId xmlns:a16="http://schemas.microsoft.com/office/drawing/2014/main" id="{8FAD1507-6C99-4F0E-A536-ECA1A63D8660}"/>
+                <a16:creationId xmlns:a16="http://schemas.microsoft.com/office/drawing/2014/main" id="{800510D9-FB59-41B2-810C-2ECC52D61B95}"/>
               </a:ext>
             </a:extLst>
           </p:cNvPr>
@@ -10919,7 +10919,7 @@
           <p:cNvPr id="35" name="">
             <a:extLst xmlns:a="http://schemas.openxmlformats.org/drawingml/2006/main">
               <a:ext uri="{FF2B5EF4-FFF2-40B4-BE49-F238E27FC236}">
-                <a16:creationId xmlns:a16="http://schemas.microsoft.com/office/drawing/2014/main" id="{0EAD8AAD-2D97-44EF-A40E-F50285A966C7}"/>
+                <a16:creationId xmlns:a16="http://schemas.microsoft.com/office/drawing/2014/main" id="{68A7598E-51FC-4DD8-83A3-AC524468C81A}"/>
               </a:ext>
             </a:extLst>
           </p:cNvPr>
@@ -10983,7 +10983,7 @@
           <p:cNvPr id="36" name="">
             <a:extLst xmlns:a="http://schemas.openxmlformats.org/drawingml/2006/main">
               <a:ext uri="{FF2B5EF4-FFF2-40B4-BE49-F238E27FC236}">
-                <a16:creationId xmlns:a16="http://schemas.microsoft.com/office/drawing/2014/main" id="{2795BFC6-8850-408D-9CC2-1D3F66C2CC4A}"/>
+                <a16:creationId xmlns:a16="http://schemas.microsoft.com/office/drawing/2014/main" id="{C7552D91-1492-4656-8EA1-26E8E97EDC65}"/>
               </a:ext>
             </a:extLst>
           </p:cNvPr>
@@ -11018,7 +11018,7 @@
           <p:cNvPr id="37" name="">
             <a:extLst xmlns:a="http://schemas.openxmlformats.org/drawingml/2006/main">
               <a:ext uri="{FF2B5EF4-FFF2-40B4-BE49-F238E27FC236}">
-                <a16:creationId xmlns:a16="http://schemas.microsoft.com/office/drawing/2014/main" id="{1BFFE895-EE71-475D-8697-5199E5840FD6}"/>
+                <a16:creationId xmlns:a16="http://schemas.microsoft.com/office/drawing/2014/main" id="{95028E1B-F848-4C5E-90BB-893C9472587D}"/>
               </a:ext>
             </a:extLst>
           </p:cNvPr>
@@ -11082,7 +11082,7 @@
           <p:cNvPr id="38" name="">
             <a:extLst xmlns:a="http://schemas.openxmlformats.org/drawingml/2006/main">
               <a:ext uri="{FF2B5EF4-FFF2-40B4-BE49-F238E27FC236}">
-                <a16:creationId xmlns:a16="http://schemas.microsoft.com/office/drawing/2014/main" id="{2C8D7BE9-8712-4CC8-9A2C-6540DF6FE796}"/>
+                <a16:creationId xmlns:a16="http://schemas.microsoft.com/office/drawing/2014/main" id="{FAF84E13-7207-400A-BA2B-B3177EFB4597}"/>
               </a:ext>
             </a:extLst>
           </p:cNvPr>
@@ -11115,7 +11115,7 @@
           <p:cNvPr id="39" name="">
             <a:extLst xmlns:a="http://schemas.openxmlformats.org/drawingml/2006/main">
               <a:ext uri="{FF2B5EF4-FFF2-40B4-BE49-F238E27FC236}">
-                <a16:creationId xmlns:a16="http://schemas.microsoft.com/office/drawing/2014/main" id="{02E6449B-B80C-4C37-A0A8-143E58A1E9F8}"/>
+                <a16:creationId xmlns:a16="http://schemas.microsoft.com/office/drawing/2014/main" id="{6FA09CBA-CE2A-489E-ADB7-C4A90B17E137}"/>
               </a:ext>
             </a:extLst>
           </p:cNvPr>
@@ -11179,7 +11179,7 @@
           <p:cNvPr id="40" name="">
             <a:extLst xmlns:a="http://schemas.openxmlformats.org/drawingml/2006/main">
               <a:ext uri="{FF2B5EF4-FFF2-40B4-BE49-F238E27FC236}">
-                <a16:creationId xmlns:a16="http://schemas.microsoft.com/office/drawing/2014/main" id="{9F88A226-E26D-4409-8762-E6491F584B8E}"/>
+                <a16:creationId xmlns:a16="http://schemas.microsoft.com/office/drawing/2014/main" id="{C6AA293E-5F9A-45AC-BA98-C51929C956FD}"/>
               </a:ext>
             </a:extLst>
           </p:cNvPr>
@@ -11214,7 +11214,7 @@
           <p:cNvPr id="41" name="">
             <a:extLst xmlns:a="http://schemas.openxmlformats.org/drawingml/2006/main">
               <a:ext uri="{FF2B5EF4-FFF2-40B4-BE49-F238E27FC236}">
-                <a16:creationId xmlns:a16="http://schemas.microsoft.com/office/drawing/2014/main" id="{F2D44F9D-373C-4597-B8DF-108EEE22E690}"/>
+                <a16:creationId xmlns:a16="http://schemas.microsoft.com/office/drawing/2014/main" id="{12D3AF5B-4945-480E-B1FF-E7C90DFC49AA}"/>
               </a:ext>
             </a:extLst>
           </p:cNvPr>
@@ -11278,7 +11278,7 @@
           <p:cNvPr id="42" name="">
             <a:extLst xmlns:a="http://schemas.openxmlformats.org/drawingml/2006/main">
               <a:ext uri="{FF2B5EF4-FFF2-40B4-BE49-F238E27FC236}">
-                <a16:creationId xmlns:a16="http://schemas.microsoft.com/office/drawing/2014/main" id="{2A20C31A-E1D7-450B-A395-35984463BDA1}"/>
+                <a16:creationId xmlns:a16="http://schemas.microsoft.com/office/drawing/2014/main" id="{5B36A2A1-C5AD-4EAD-BE40-42A1192CC63E}"/>
               </a:ext>
             </a:extLst>
           </p:cNvPr>
@@ -11342,7 +11342,7 @@
           <p:cNvPr id="43" name="">
             <a:extLst xmlns:a="http://schemas.openxmlformats.org/drawingml/2006/main">
               <a:ext uri="{FF2B5EF4-FFF2-40B4-BE49-F238E27FC236}">
-                <a16:creationId xmlns:a16="http://schemas.microsoft.com/office/drawing/2014/main" id="{FCFBF4E6-8460-4A5C-99BF-D77CE80279B5}"/>
+                <a16:creationId xmlns:a16="http://schemas.microsoft.com/office/drawing/2014/main" id="{FA54C506-8D05-4AF0-979B-46D4202606D5}"/>
               </a:ext>
             </a:extLst>
           </p:cNvPr>
@@ -11406,7 +11406,7 @@
           <p:cNvPr id="44" name="">
             <a:extLst xmlns:a="http://schemas.openxmlformats.org/drawingml/2006/main">
               <a:ext uri="{FF2B5EF4-FFF2-40B4-BE49-F238E27FC236}">
-                <a16:creationId xmlns:a16="http://schemas.microsoft.com/office/drawing/2014/main" id="{79255992-58D8-4994-B457-CD5639E7B33D}"/>
+                <a16:creationId xmlns:a16="http://schemas.microsoft.com/office/drawing/2014/main" id="{09CD09EE-2178-4B85-82C3-34D5D424B3AE}"/>
               </a:ext>
             </a:extLst>
           </p:cNvPr>
@@ -11468,7 +11468,7 @@
     </p:spTree>
     <p:extLst>
       <p:ext uri="{BB962C8B-B14F-4D97-AF65-F5344CB8AC3E}">
-        <p14:creationId xmlns:p14="http://schemas.microsoft.com/office/powerpoint/2010/main" val="119865075"/>
+        <p14:creationId xmlns:p14="http://schemas.microsoft.com/office/powerpoint/2010/main" val="1100079302"/>
       </p:ext>
     </p:extLst>
   </p:cSld>

</xml_diff>